<commit_message>
Recolor both decks to a low-saturation slate, rebuild the architecture slide
The navy (1E2761) read as heavy next to the app screenshots; both decks now use a
desaturated slate (434E60) with muted supporting tones. Contrast on the dark
surface was kept above 4:1 for body text.

The engineer deck's first slide is now the architecture itself: three labelled
bands (取込 / 変換 / 出力) showing what each stage does and the counts that matter,
with the transitions annotated, and the tech stack moved to a single strip at the
bottom. The tech-choice rationale that used to fill this slide is already covered
by the decision slides that follow. The output row has no arrows between its two
boxes — the dashboard and the assistant are parallel consumers, not a sequence.

Co-Authored-By: Claude Opus 5 <noreply@anthropic.com>
</commit_message>
<xml_diff>
--- a/docs/mini-nowcast-engineering.pptx
+++ b/docs/mini-nowcast-engineering.pptx
@@ -1302,7 +1302,7 @@
     <p:bg>
       <p:bgPr>
         <a:solidFill>
-          <a:srgbClr val="1E2761"/>
+          <a:srgbClr val="434E60"/>
         </a:solidFill>
       </p:bgPr>
     </p:bg>
@@ -1347,7 +1347,7 @@
             <a:r>
               <a:rPr lang="en-US" sz="1200" b="1" spc="100" kern="0" dirty="0">
                 <a:solidFill>
-                  <a:srgbClr val="8FB3E8"/>
+                  <a:srgbClr val="AEBACB"/>
                 </a:solidFill>
                 <a:latin typeface="Yu Gothic" pitchFamily="34" charset="0"/>
                 <a:ea typeface="Yu Gothic" pitchFamily="34" charset="-122"/>
@@ -1392,7 +1392,7 @@
                 <a:ea typeface="Yu Gothic" pitchFamily="34" charset="-122"/>
                 <a:cs typeface="Yu Gothic" pitchFamily="34" charset="-120"/>
               </a:rPr>
-              <a:t>全体像と技術選定</a:t>
+              <a:t>アーキテクチャ</a:t>
             </a:r>
             <a:endParaRPr lang="en-US" sz="2800" dirty="0"/>
           </a:p>
@@ -1406,34 +1406,34 @@
         </p:nvSpPr>
         <p:spPr>
           <a:xfrm>
-            <a:off x="548640" y="1234440"/>
-            <a:ext cx="11064240" cy="274320"/>
-          </a:xfrm>
-          <a:prstGeom prst="rect">
-            <a:avLst/>
-          </a:prstGeom>
-          <a:noFill/>
-          <a:ln/>
-        </p:spPr>
-        <p:txBody>
-          <a:bodyPr wrap="square" lIns="0" tIns="0" rIns="0" bIns="0" rtlCol="0" anchor="ctr"/>
-          <a:lstStyle/>
-          <a:p>
-            <a:pPr indent="0" marL="0">
-              <a:buNone/>
-            </a:pPr>
-            <a:r>
-              <a:rPr lang="en-US" sz="1250" dirty="0">
-                <a:solidFill>
-                  <a:srgbClr val="CADCFC"/>
-                </a:solidFill>
-                <a:latin typeface="Yu Gothic" pitchFamily="34" charset="0"/>
-                <a:ea typeface="Yu Gothic" pitchFamily="34" charset="-122"/>
-                <a:cs typeface="Yu Gothic" pitchFamily="34" charset="-120"/>
-              </a:rPr>
-              <a:t>購買データ（UCI Online Retail II, 英国小売 2年分）から物価指数をつくり、そのデータに自然言語で質問できるようにした小さなデータ基盤です。</a:t>
-            </a:r>
-            <a:endParaRPr lang="en-US" sz="1250" dirty="0"/>
+            <a:off x="548640" y="1636776"/>
+            <a:ext cx="1371600" cy="292608"/>
+          </a:xfrm>
+          <a:prstGeom prst="rect">
+            <a:avLst/>
+          </a:prstGeom>
+          <a:noFill/>
+          <a:ln/>
+        </p:spPr>
+        <p:txBody>
+          <a:bodyPr wrap="square" lIns="0" tIns="0" rIns="0" bIns="0" rtlCol="0" anchor="ctr"/>
+          <a:lstStyle/>
+          <a:p>
+            <a:pPr indent="0" marL="0">
+              <a:buNone/>
+            </a:pPr>
+            <a:r>
+              <a:rPr lang="en-US" sz="1150" b="1" dirty="0">
+                <a:solidFill>
+                  <a:srgbClr val="AEBACB"/>
+                </a:solidFill>
+                <a:latin typeface="Yu Gothic" pitchFamily="34" charset="0"/>
+                <a:ea typeface="Yu Gothic" pitchFamily="34" charset="-122"/>
+                <a:cs typeface="Yu Gothic" pitchFamily="34" charset="-120"/>
+              </a:rPr>
+              <a:t>① 取込</a:t>
+            </a:r>
+            <a:endParaRPr lang="en-US" sz="1150" dirty="0"/>
           </a:p>
         </p:txBody>
       </p:sp>
@@ -1445,16 +1445,16 @@
         </p:nvSpPr>
         <p:spPr>
           <a:xfrm>
-            <a:off x="548640" y="1783080"/>
-            <a:ext cx="1993392" cy="1234440"/>
+            <a:off x="1965960" y="1325880"/>
+            <a:ext cx="3057144" cy="914400"/>
           </a:xfrm>
           <a:prstGeom prst="roundRect">
             <a:avLst>
-              <a:gd name="adj" fmla="val 5926"/>
+              <a:gd name="adj" fmla="val 8000"/>
             </a:avLst>
           </a:prstGeom>
           <a:solidFill>
-            <a:srgbClr val="2E3C7A"/>
+            <a:srgbClr val="556175"/>
           </a:solidFill>
           <a:ln/>
         </p:spPr>
@@ -1467,24 +1467,24 @@
         </p:nvSpPr>
         <p:spPr>
           <a:xfrm>
-            <a:off x="658368" y="1929384"/>
-            <a:ext cx="1773936" cy="274320"/>
-          </a:xfrm>
-          <a:prstGeom prst="rect">
-            <a:avLst/>
-          </a:prstGeom>
-          <a:noFill/>
-          <a:ln/>
-        </p:spPr>
-        <p:txBody>
-          <a:bodyPr wrap="square" lIns="0" tIns="0" rIns="0" bIns="0" rtlCol="0" anchor="ctr"/>
-          <a:lstStyle/>
-          <a:p>
-            <a:pPr algn="ctr" indent="0" marL="0">
-              <a:buNone/>
-            </a:pPr>
-            <a:r>
-              <a:rPr lang="en-US" sz="1200" b="1" dirty="0">
+            <a:off x="2112264" y="1444752"/>
+            <a:ext cx="2764536" cy="237744"/>
+          </a:xfrm>
+          <a:prstGeom prst="rect">
+            <a:avLst/>
+          </a:prstGeom>
+          <a:noFill/>
+          <a:ln/>
+        </p:spPr>
+        <p:txBody>
+          <a:bodyPr wrap="square" lIns="0" tIns="0" rIns="0" bIns="0" rtlCol="0" anchor="ctr"/>
+          <a:lstStyle/>
+          <a:p>
+            <a:pPr indent="0" marL="0">
+              <a:buNone/>
+            </a:pPr>
+            <a:r>
+              <a:rPr lang="en-US" sz="1150" b="1" dirty="0">
                 <a:solidFill>
                   <a:srgbClr val="FFFFFF"/>
                 </a:solidFill>
@@ -1492,9 +1492,9 @@
                 <a:ea typeface="Yu Gothic" pitchFamily="34" charset="-122"/>
                 <a:cs typeface="Yu Gothic" pitchFamily="34" charset="-120"/>
               </a:rPr>
-              <a:t>xlsx</a:t>
-            </a:r>
-            <a:endParaRPr lang="en-US" sz="1200" dirty="0"/>
+              <a:t>xlsx（公開データ）</a:t>
+            </a:r>
+            <a:endParaRPr lang="en-US" sz="1150" dirty="0"/>
           </a:p>
         </p:txBody>
       </p:sp>
@@ -1506,57 +1506,37 @@
         </p:nvSpPr>
         <p:spPr>
           <a:xfrm>
-            <a:off x="640080" y="2240280"/>
-            <a:ext cx="1810512" cy="667512"/>
-          </a:xfrm>
-          <a:prstGeom prst="rect">
-            <a:avLst/>
-          </a:prstGeom>
-          <a:noFill/>
-          <a:ln/>
-        </p:spPr>
-        <p:txBody>
-          <a:bodyPr wrap="square" lIns="0" tIns="0" rIns="0" bIns="0" rtlCol="0" anchor="ctr"/>
-          <a:lstStyle/>
-          <a:p>
-            <a:pPr algn="ctr" indent="0" marL="0">
+            <a:off x="2112264" y="1709928"/>
+            <a:ext cx="2764536" cy="438912"/>
+          </a:xfrm>
+          <a:prstGeom prst="rect">
+            <a:avLst/>
+          </a:prstGeom>
+          <a:noFill/>
+          <a:ln/>
+        </p:spPr>
+        <p:txBody>
+          <a:bodyPr wrap="square" lIns="0" tIns="0" rIns="0" bIns="0" rtlCol="0" anchor="ctr"/>
+          <a:lstStyle/>
+          <a:p>
+            <a:pPr indent="0" marL="0">
               <a:lnSpc>
-                <a:spcPts val="1400"/>
+                <a:spcPts val="1300"/>
               </a:lnSpc>
               <a:buNone/>
             </a:pPr>
             <a:r>
-              <a:rPr lang="en-US" sz="1000" dirty="0">
-                <a:solidFill>
-                  <a:srgbClr val="CADCFC"/>
-                </a:solidFill>
-                <a:latin typeface="Yu Gothic" pitchFamily="34" charset="0"/>
-                <a:ea typeface="Yu Gothic" pitchFamily="34" charset="-122"/>
-                <a:cs typeface="Yu Gothic" pitchFamily="34" charset="-120"/>
-              </a:rPr>
-              <a:t>1,067,371 行</a:t>
-            </a:r>
-            <a:endParaRPr lang="en-US" sz="1000" dirty="0"/>
-          </a:p>
-          <a:p>
-            <a:pPr algn="ctr" indent="0" marL="0">
-              <a:lnSpc>
-                <a:spcPts val="1400"/>
-              </a:lnSpc>
-              <a:buNone/>
-            </a:pPr>
-            <a:r>
-              <a:rPr lang="en-US" sz="1000" dirty="0">
-                <a:solidFill>
-                  <a:srgbClr val="CADCFC"/>
-                </a:solidFill>
-                <a:latin typeface="Yu Gothic" pitchFamily="34" charset="0"/>
-                <a:ea typeface="Yu Gothic" pitchFamily="34" charset="-122"/>
-                <a:cs typeface="Yu Gothic" pitchFamily="34" charset="-120"/>
-              </a:rPr>
-              <a:t>公開データ</a:t>
-            </a:r>
-            <a:endParaRPr lang="en-US" sz="1000" dirty="0"/>
+              <a:rPr lang="en-US" sz="950" dirty="0">
+                <a:solidFill>
+                  <a:srgbClr val="DCE2EA"/>
+                </a:solidFill>
+                <a:latin typeface="Yu Gothic" pitchFamily="34" charset="0"/>
+                <a:ea typeface="Yu Gothic" pitchFamily="34" charset="-122"/>
+                <a:cs typeface="Yu Gothic" pitchFamily="34" charset="-120"/>
+              </a:rPr>
+              <a:t>UCI Online Retail II ／ 英国小売 2 年分 ／ 1,067,371 行</a:t>
+            </a:r>
+            <a:endParaRPr lang="en-US" sz="950" dirty="0"/>
           </a:p>
         </p:txBody>
       </p:sp>
@@ -1568,14 +1548,14 @@
         </p:nvSpPr>
         <p:spPr>
           <a:xfrm>
-            <a:off x="2583180" y="2308860"/>
-            <a:ext cx="192024" cy="182880"/>
+            <a:off x="5055108" y="1700784"/>
+            <a:ext cx="173736" cy="164592"/>
           </a:xfrm>
           <a:prstGeom prst="rightArrow">
             <a:avLst/>
           </a:prstGeom>
           <a:solidFill>
-            <a:srgbClr val="8FB3E8"/>
+            <a:srgbClr val="AEBACB"/>
           </a:solidFill>
           <a:ln/>
         </p:spPr>
@@ -1588,16 +1568,16 @@
         </p:nvSpPr>
         <p:spPr>
           <a:xfrm>
-            <a:off x="2816352" y="1783080"/>
-            <a:ext cx="1993392" cy="1234440"/>
+            <a:off x="5260848" y="1325880"/>
+            <a:ext cx="3057144" cy="914400"/>
           </a:xfrm>
           <a:prstGeom prst="roundRect">
             <a:avLst>
-              <a:gd name="adj" fmla="val 5926"/>
+              <a:gd name="adj" fmla="val 8000"/>
             </a:avLst>
           </a:prstGeom>
           <a:solidFill>
-            <a:srgbClr val="2E3C7A"/>
+            <a:srgbClr val="556175"/>
           </a:solidFill>
           <a:ln/>
         </p:spPr>
@@ -1610,24 +1590,24 @@
         </p:nvSpPr>
         <p:spPr>
           <a:xfrm>
-            <a:off x="2926080" y="1929384"/>
-            <a:ext cx="1773936" cy="274320"/>
-          </a:xfrm>
-          <a:prstGeom prst="rect">
-            <a:avLst/>
-          </a:prstGeom>
-          <a:noFill/>
-          <a:ln/>
-        </p:spPr>
-        <p:txBody>
-          <a:bodyPr wrap="square" lIns="0" tIns="0" rIns="0" bIns="0" rtlCol="0" anchor="ctr"/>
-          <a:lstStyle/>
-          <a:p>
-            <a:pPr algn="ctr" indent="0" marL="0">
-              <a:buNone/>
-            </a:pPr>
-            <a:r>
-              <a:rPr lang="en-US" sz="1200" b="1" dirty="0">
+            <a:off x="5407152" y="1444752"/>
+            <a:ext cx="2764536" cy="237744"/>
+          </a:xfrm>
+          <a:prstGeom prst="rect">
+            <a:avLst/>
+          </a:prstGeom>
+          <a:noFill/>
+          <a:ln/>
+        </p:spPr>
+        <p:txBody>
+          <a:bodyPr wrap="square" lIns="0" tIns="0" rIns="0" bIns="0" rtlCol="0" anchor="ctr"/>
+          <a:lstStyle/>
+          <a:p>
+            <a:pPr indent="0" marL="0">
+              <a:buNone/>
+            </a:pPr>
+            <a:r>
+              <a:rPr lang="en-US" sz="1150" b="1" dirty="0">
                 <a:solidFill>
                   <a:srgbClr val="FFFFFF"/>
                 </a:solidFill>
@@ -1635,9 +1615,9 @@
                 <a:ea typeface="Yu Gothic" pitchFamily="34" charset="-122"/>
                 <a:cs typeface="Yu Gothic" pitchFamily="34" charset="-120"/>
               </a:rPr>
-              <a:t>ingest（Python）</a:t>
-            </a:r>
-            <a:endParaRPr lang="en-US" sz="1200" dirty="0"/>
+              <a:t>ingest/load_raw.py</a:t>
+            </a:r>
+            <a:endParaRPr lang="en-US" sz="1150" dirty="0"/>
           </a:p>
         </p:txBody>
       </p:sp>
@@ -1649,57 +1629,37 @@
         </p:nvSpPr>
         <p:spPr>
           <a:xfrm>
-            <a:off x="2907792" y="2240280"/>
-            <a:ext cx="1810512" cy="667512"/>
-          </a:xfrm>
-          <a:prstGeom prst="rect">
-            <a:avLst/>
-          </a:prstGeom>
-          <a:noFill/>
-          <a:ln/>
-        </p:spPr>
-        <p:txBody>
-          <a:bodyPr wrap="square" lIns="0" tIns="0" rIns="0" bIns="0" rtlCol="0" anchor="ctr"/>
-          <a:lstStyle/>
-          <a:p>
-            <a:pPr algn="ctr" indent="0" marL="0">
+            <a:off x="5407152" y="1709928"/>
+            <a:ext cx="2764536" cy="438912"/>
+          </a:xfrm>
+          <a:prstGeom prst="rect">
+            <a:avLst/>
+          </a:prstGeom>
+          <a:noFill/>
+          <a:ln/>
+        </p:spPr>
+        <p:txBody>
+          <a:bodyPr wrap="square" lIns="0" tIns="0" rIns="0" bIns="0" rtlCol="0" anchor="ctr"/>
+          <a:lstStyle/>
+          <a:p>
+            <a:pPr indent="0" marL="0">
               <a:lnSpc>
-                <a:spcPts val="1400"/>
+                <a:spcPts val="1300"/>
               </a:lnSpc>
               <a:buNone/>
             </a:pPr>
             <a:r>
-              <a:rPr lang="en-US" sz="1000" dirty="0">
-                <a:solidFill>
-                  <a:srgbClr val="CADCFC"/>
-                </a:solidFill>
-                <a:latin typeface="Yu Gothic" pitchFamily="34" charset="0"/>
-                <a:ea typeface="Yu Gothic" pitchFamily="34" charset="-122"/>
-                <a:cs typeface="Yu Gothic" pitchFamily="34" charset="-120"/>
-              </a:rPr>
-              <a:t>Parquet 化 → DuckDB</a:t>
-            </a:r>
-            <a:endParaRPr lang="en-US" sz="1000" dirty="0"/>
-          </a:p>
-          <a:p>
-            <a:pPr algn="ctr" indent="0" marL="0">
-              <a:lnSpc>
-                <a:spcPts val="1400"/>
-              </a:lnSpc>
-              <a:buNone/>
-            </a:pPr>
-            <a:r>
-              <a:rPr lang="en-US" sz="1000" dirty="0">
-                <a:solidFill>
-                  <a:srgbClr val="CADCFC"/>
-                </a:solidFill>
-                <a:latin typeface="Yu Gothic" pitchFamily="34" charset="0"/>
-                <a:ea typeface="Yu Gothic" pitchFamily="34" charset="-122"/>
-                <a:cs typeface="Yu Gothic" pitchFamily="34" charset="-120"/>
-              </a:rPr>
-              <a:t>取込行数をログに記録</a:t>
-            </a:r>
-            <a:endParaRPr lang="en-US" sz="1000" dirty="0"/>
+              <a:rPr lang="en-US" sz="950" dirty="0">
+                <a:solidFill>
+                  <a:srgbClr val="DCE2EA"/>
+                </a:solidFill>
+                <a:latin typeface="Yu Gothic" pitchFamily="34" charset="0"/>
+                <a:ea typeface="Yu Gothic" pitchFamily="34" charset="-122"/>
+                <a:cs typeface="Yu Gothic" pitchFamily="34" charset="-120"/>
+              </a:rPr>
+              <a:t>Parquet 化してキャッシュ ／ 取込行数を ingest_log に記録</a:t>
+            </a:r>
+            <a:endParaRPr lang="en-US" sz="950" dirty="0"/>
           </a:p>
         </p:txBody>
       </p:sp>
@@ -1711,14 +1671,14 @@
         </p:nvSpPr>
         <p:spPr>
           <a:xfrm>
-            <a:off x="4850892" y="2308860"/>
-            <a:ext cx="192024" cy="182880"/>
+            <a:off x="8349996" y="1700784"/>
+            <a:ext cx="173736" cy="164592"/>
           </a:xfrm>
           <a:prstGeom prst="rightArrow">
             <a:avLst/>
           </a:prstGeom>
           <a:solidFill>
-            <a:srgbClr val="8FB3E8"/>
+            <a:srgbClr val="AEBACB"/>
           </a:solidFill>
           <a:ln/>
         </p:spPr>
@@ -1731,16 +1691,16 @@
         </p:nvSpPr>
         <p:spPr>
           <a:xfrm>
-            <a:off x="5084064" y="1783080"/>
-            <a:ext cx="1993392" cy="1234440"/>
+            <a:off x="8555736" y="1325880"/>
+            <a:ext cx="3057144" cy="914400"/>
           </a:xfrm>
           <a:prstGeom prst="roundRect">
             <a:avLst>
-              <a:gd name="adj" fmla="val 5926"/>
+              <a:gd name="adj" fmla="val 8000"/>
             </a:avLst>
           </a:prstGeom>
           <a:solidFill>
-            <a:srgbClr val="CADCFC"/>
+            <a:srgbClr val="556175"/>
           </a:solidFill>
           <a:ln/>
         </p:spPr>
@@ -1753,34 +1713,34 @@
         </p:nvSpPr>
         <p:spPr>
           <a:xfrm>
-            <a:off x="5193792" y="1929384"/>
-            <a:ext cx="1773936" cy="274320"/>
-          </a:xfrm>
-          <a:prstGeom prst="rect">
-            <a:avLst/>
-          </a:prstGeom>
-          <a:noFill/>
-          <a:ln/>
-        </p:spPr>
-        <p:txBody>
-          <a:bodyPr wrap="square" lIns="0" tIns="0" rIns="0" bIns="0" rtlCol="0" anchor="ctr"/>
-          <a:lstStyle/>
-          <a:p>
-            <a:pPr algn="ctr" indent="0" marL="0">
-              <a:buNone/>
-            </a:pPr>
-            <a:r>
-              <a:rPr lang="en-US" sz="1200" b="1" dirty="0">
-                <a:solidFill>
-                  <a:srgbClr val="1E2761"/>
-                </a:solidFill>
-                <a:latin typeface="Yu Gothic" pitchFamily="34" charset="0"/>
-                <a:ea typeface="Yu Gothic" pitchFamily="34" charset="-122"/>
-                <a:cs typeface="Yu Gothic" pitchFamily="34" charset="-120"/>
-              </a:rPr>
-              <a:t>dbt</a:t>
-            </a:r>
-            <a:endParaRPr lang="en-US" sz="1200" dirty="0"/>
+            <a:off x="8702040" y="1444752"/>
+            <a:ext cx="2764536" cy="237744"/>
+          </a:xfrm>
+          <a:prstGeom prst="rect">
+            <a:avLst/>
+          </a:prstGeom>
+          <a:noFill/>
+          <a:ln/>
+        </p:spPr>
+        <p:txBody>
+          <a:bodyPr wrap="square" lIns="0" tIns="0" rIns="0" bIns="0" rtlCol="0" anchor="ctr"/>
+          <a:lstStyle/>
+          <a:p>
+            <a:pPr indent="0" marL="0">
+              <a:buNone/>
+            </a:pPr>
+            <a:r>
+              <a:rPr lang="en-US" sz="1150" b="1" dirty="0">
+                <a:solidFill>
+                  <a:srgbClr val="FFFFFF"/>
+                </a:solidFill>
+                <a:latin typeface="Yu Gothic" pitchFamily="34" charset="0"/>
+                <a:ea typeface="Yu Gothic" pitchFamily="34" charset="-122"/>
+                <a:cs typeface="Yu Gothic" pitchFamily="34" charset="-120"/>
+              </a:rPr>
+              <a:t>DuckDB : raw</a:t>
+            </a:r>
+            <a:endParaRPr lang="en-US" sz="1150" dirty="0"/>
           </a:p>
         </p:txBody>
       </p:sp>
@@ -1792,57 +1752,37 @@
         </p:nvSpPr>
         <p:spPr>
           <a:xfrm>
-            <a:off x="5175504" y="2240280"/>
-            <a:ext cx="1810512" cy="667512"/>
-          </a:xfrm>
-          <a:prstGeom prst="rect">
-            <a:avLst/>
-          </a:prstGeom>
-          <a:noFill/>
-          <a:ln/>
-        </p:spPr>
-        <p:txBody>
-          <a:bodyPr wrap="square" lIns="0" tIns="0" rIns="0" bIns="0" rtlCol="0" anchor="ctr"/>
-          <a:lstStyle/>
-          <a:p>
-            <a:pPr algn="ctr" indent="0" marL="0">
+            <a:off x="8702040" y="1709928"/>
+            <a:ext cx="2764536" cy="438912"/>
+          </a:xfrm>
+          <a:prstGeom prst="rect">
+            <a:avLst/>
+          </a:prstGeom>
+          <a:noFill/>
+          <a:ln/>
+        </p:spPr>
+        <p:txBody>
+          <a:bodyPr wrap="square" lIns="0" tIns="0" rIns="0" bIns="0" rtlCol="0" anchor="ctr"/>
+          <a:lstStyle/>
+          <a:p>
+            <a:pPr indent="0" marL="0">
               <a:lnSpc>
-                <a:spcPts val="1400"/>
+                <a:spcPts val="1300"/>
               </a:lnSpc>
               <a:buNone/>
             </a:pPr>
             <a:r>
-              <a:rPr lang="en-US" sz="1000" dirty="0">
-                <a:solidFill>
-                  <a:srgbClr val="1E2761"/>
-                </a:solidFill>
-                <a:latin typeface="Yu Gothic" pitchFamily="34" charset="0"/>
-                <a:ea typeface="Yu Gothic" pitchFamily="34" charset="-122"/>
-                <a:cs typeface="Yu Gothic" pitchFamily="34" charset="-120"/>
-              </a:rPr>
-              <a:t>staging → intermediate → marts</a:t>
-            </a:r>
-            <a:endParaRPr lang="en-US" sz="1000" dirty="0"/>
-          </a:p>
-          <a:p>
-            <a:pPr algn="ctr" indent="0" marL="0">
-              <a:lnSpc>
-                <a:spcPts val="1400"/>
-              </a:lnSpc>
-              <a:buNone/>
-            </a:pPr>
-            <a:r>
-              <a:rPr lang="en-US" sz="1000" dirty="0">
-                <a:solidFill>
-                  <a:srgbClr val="1E2761"/>
-                </a:solidFill>
-                <a:latin typeface="Yu Gothic" pitchFamily="34" charset="0"/>
-                <a:ea typeface="Yu Gothic" pitchFamily="34" charset="-122"/>
-                <a:cs typeface="Yu Gothic" pitchFamily="34" charset="-120"/>
-              </a:rPr>
-              <a:t>16 モデル / 28 テスト</a:t>
-            </a:r>
-            <a:endParaRPr lang="en-US" sz="1000" dirty="0"/>
+              <a:rPr lang="en-US" sz="950" dirty="0">
+                <a:solidFill>
+                  <a:srgbClr val="DCE2EA"/>
+                </a:solidFill>
+                <a:latin typeface="Yu Gothic" pitchFamily="34" charset="0"/>
+                <a:ea typeface="Yu Gothic" pitchFamily="34" charset="-122"/>
+                <a:cs typeface="Yu Gothic" pitchFamily="34" charset="-120"/>
+              </a:rPr>
+              <a:t>単一ファイル 166 MB ／ 型はソースのまま保持</a:t>
+            </a:r>
+            <a:endParaRPr lang="en-US" sz="950" dirty="0"/>
           </a:p>
         </p:txBody>
       </p:sp>
@@ -1854,66 +1794,144 @@
         </p:nvSpPr>
         <p:spPr>
           <a:xfrm>
-            <a:off x="7118604" y="2308860"/>
-            <a:ext cx="192024" cy="182880"/>
-          </a:xfrm>
-          <a:prstGeom prst="rightArrow">
+            <a:off x="6583680" y="2331720"/>
+            <a:ext cx="164592" cy="237744"/>
+          </a:xfrm>
+          <a:prstGeom prst="downArrow">
             <a:avLst/>
           </a:prstGeom>
           <a:solidFill>
-            <a:srgbClr val="8FB3E8"/>
+            <a:srgbClr val="AEBACB"/>
           </a:solidFill>
           <a:ln/>
         </p:spPr>
       </p:sp>
       <p:sp>
         <p:nvSpPr>
-          <p:cNvPr id="17" name="Shape 15"/>
+          <p:cNvPr id="17" name="Text 15"/>
+          <p:cNvSpPr txBox="1"/>
+          <p:nvPr/>
+        </p:nvSpPr>
+        <p:spPr>
+          <a:xfrm>
+            <a:off x="6949440" y="2313432"/>
+            <a:ext cx="4663440" cy="274320"/>
+          </a:xfrm>
+          <a:prstGeom prst="rect">
+            <a:avLst/>
+          </a:prstGeom>
+          <a:noFill/>
+          <a:ln/>
+        </p:spPr>
+        <p:txBody>
+          <a:bodyPr wrap="square" lIns="0" tIns="0" rIns="0" bIns="0" rtlCol="0" anchor="ctr"/>
+          <a:lstStyle/>
+          <a:p>
+            <a:pPr indent="0" marL="0">
+              <a:buNone/>
+            </a:pPr>
+            <a:r>
+              <a:rPr lang="en-US" sz="950" dirty="0">
+                <a:solidFill>
+                  <a:srgbClr val="AEBACB"/>
+                </a:solidFill>
+                <a:latin typeface="Yu Gothic" pitchFamily="34" charset="0"/>
+                <a:ea typeface="Yu Gothic" pitchFamily="34" charset="-122"/>
+                <a:cs typeface="Yu Gothic" pitchFamily="34" charset="-120"/>
+              </a:rPr>
+              <a:t>ここから先は SQL（dbt がモデルの依存 DAG を決定：16 モデル）</a:t>
+            </a:r>
+            <a:endParaRPr lang="en-US" sz="950" dirty="0"/>
+          </a:p>
+        </p:txBody>
+      </p:sp>
+      <p:sp>
+        <p:nvSpPr>
+          <p:cNvPr id="18" name="Text 16"/>
+          <p:cNvSpPr txBox="1"/>
+          <p:nvPr/>
+        </p:nvSpPr>
+        <p:spPr>
+          <a:xfrm>
+            <a:off x="548640" y="3076956"/>
+            <a:ext cx="1371600" cy="292608"/>
+          </a:xfrm>
+          <a:prstGeom prst="rect">
+            <a:avLst/>
+          </a:prstGeom>
+          <a:noFill/>
+          <a:ln/>
+        </p:spPr>
+        <p:txBody>
+          <a:bodyPr wrap="square" lIns="0" tIns="0" rIns="0" bIns="0" rtlCol="0" anchor="ctr"/>
+          <a:lstStyle/>
+          <a:p>
+            <a:pPr indent="0" marL="0">
+              <a:buNone/>
+            </a:pPr>
+            <a:r>
+              <a:rPr lang="en-US" sz="1150" b="1" dirty="0">
+                <a:solidFill>
+                  <a:srgbClr val="AEBACB"/>
+                </a:solidFill>
+                <a:latin typeface="Yu Gothic" pitchFamily="34" charset="0"/>
+                <a:ea typeface="Yu Gothic" pitchFamily="34" charset="-122"/>
+                <a:cs typeface="Yu Gothic" pitchFamily="34" charset="-120"/>
+              </a:rPr>
+              <a:t>② 変換 (dbt)</a:t>
+            </a:r>
+            <a:endParaRPr lang="en-US" sz="1150" dirty="0"/>
+          </a:p>
+        </p:txBody>
+      </p:sp>
+      <p:sp>
+        <p:nvSpPr>
+          <p:cNvPr id="19" name="Shape 17"/>
           <p:cNvSpPr/>
           <p:nvPr/>
         </p:nvSpPr>
         <p:spPr>
           <a:xfrm>
-            <a:off x="7351776" y="1783080"/>
-            <a:ext cx="1993392" cy="1234440"/>
+            <a:off x="1965960" y="2697480"/>
+            <a:ext cx="3057144" cy="1051560"/>
           </a:xfrm>
           <a:prstGeom prst="roundRect">
             <a:avLst>
-              <a:gd name="adj" fmla="val 5926"/>
+              <a:gd name="adj" fmla="val 6957"/>
             </a:avLst>
           </a:prstGeom>
           <a:solidFill>
-            <a:srgbClr val="2E3C7A"/>
+            <a:srgbClr val="556175"/>
           </a:solidFill>
           <a:ln/>
         </p:spPr>
       </p:sp>
       <p:sp>
         <p:nvSpPr>
-          <p:cNvPr id="18" name="Text 16"/>
-          <p:cNvSpPr txBox="1"/>
-          <p:nvPr/>
-        </p:nvSpPr>
-        <p:spPr>
-          <a:xfrm>
-            <a:off x="7461504" y="1929384"/>
-            <a:ext cx="1773936" cy="274320"/>
-          </a:xfrm>
-          <a:prstGeom prst="rect">
-            <a:avLst/>
-          </a:prstGeom>
-          <a:noFill/>
-          <a:ln/>
-        </p:spPr>
-        <p:txBody>
-          <a:bodyPr wrap="square" lIns="0" tIns="0" rIns="0" bIns="0" rtlCol="0" anchor="ctr"/>
-          <a:lstStyle/>
-          <a:p>
-            <a:pPr algn="ctr" indent="0" marL="0">
-              <a:buNone/>
-            </a:pPr>
-            <a:r>
-              <a:rPr lang="en-US" sz="1200" b="1" dirty="0">
+          <p:cNvPr id="20" name="Text 18"/>
+          <p:cNvSpPr txBox="1"/>
+          <p:nvPr/>
+        </p:nvSpPr>
+        <p:spPr>
+          <a:xfrm>
+            <a:off x="2112264" y="2816352"/>
+            <a:ext cx="2764536" cy="237744"/>
+          </a:xfrm>
+          <a:prstGeom prst="rect">
+            <a:avLst/>
+          </a:prstGeom>
+          <a:noFill/>
+          <a:ln/>
+        </p:spPr>
+        <p:txBody>
+          <a:bodyPr wrap="square" lIns="0" tIns="0" rIns="0" bIns="0" rtlCol="0" anchor="ctr"/>
+          <a:lstStyle/>
+          <a:p>
+            <a:pPr indent="0" marL="0">
+              <a:buNone/>
+            </a:pPr>
+            <a:r>
+              <a:rPr lang="en-US" sz="1150" b="1" dirty="0">
                 <a:solidFill>
                   <a:srgbClr val="FFFFFF"/>
                 </a:solidFill>
@@ -1921,142 +1939,122 @@
                 <a:ea typeface="Yu Gothic" pitchFamily="34" charset="-122"/>
                 <a:cs typeface="Yu Gothic" pitchFamily="34" charset="-120"/>
               </a:rPr>
-              <a:t>DuckDB</a:t>
-            </a:r>
-            <a:endParaRPr lang="en-US" sz="1200" dirty="0"/>
-          </a:p>
-        </p:txBody>
-      </p:sp>
-      <p:sp>
-        <p:nvSpPr>
-          <p:cNvPr id="19" name="Text 17"/>
-          <p:cNvSpPr txBox="1"/>
-          <p:nvPr/>
-        </p:nvSpPr>
-        <p:spPr>
-          <a:xfrm>
-            <a:off x="7443216" y="2240280"/>
-            <a:ext cx="1810512" cy="667512"/>
-          </a:xfrm>
-          <a:prstGeom prst="rect">
-            <a:avLst/>
-          </a:prstGeom>
-          <a:noFill/>
-          <a:ln/>
-        </p:spPr>
-        <p:txBody>
-          <a:bodyPr wrap="square" lIns="0" tIns="0" rIns="0" bIns="0" rtlCol="0" anchor="ctr"/>
-          <a:lstStyle/>
-          <a:p>
-            <a:pPr algn="ctr" indent="0" marL="0">
+              <a:t>staging</a:t>
+            </a:r>
+            <a:endParaRPr lang="en-US" sz="1150" dirty="0"/>
+          </a:p>
+        </p:txBody>
+      </p:sp>
+      <p:sp>
+        <p:nvSpPr>
+          <p:cNvPr id="21" name="Text 19"/>
+          <p:cNvSpPr txBox="1"/>
+          <p:nvPr/>
+        </p:nvSpPr>
+        <p:spPr>
+          <a:xfrm>
+            <a:off x="2112264" y="3081528"/>
+            <a:ext cx="2764536" cy="576072"/>
+          </a:xfrm>
+          <a:prstGeom prst="rect">
+            <a:avLst/>
+          </a:prstGeom>
+          <a:noFill/>
+          <a:ln/>
+        </p:spPr>
+        <p:txBody>
+          <a:bodyPr wrap="square" lIns="0" tIns="0" rIns="0" bIns="0" rtlCol="0" anchor="ctr"/>
+          <a:lstStyle/>
+          <a:p>
+            <a:pPr indent="0" marL="0">
               <a:lnSpc>
-                <a:spcPts val="1400"/>
+                <a:spcPts val="1300"/>
               </a:lnSpc>
               <a:buNone/>
             </a:pPr>
             <a:r>
-              <a:rPr lang="en-US" sz="1000" dirty="0">
-                <a:solidFill>
-                  <a:srgbClr val="CADCFC"/>
-                </a:solidFill>
-                <a:latin typeface="Yu Gothic" pitchFamily="34" charset="0"/>
-                <a:ea typeface="Yu Gothic" pitchFamily="34" charset="-122"/>
-                <a:cs typeface="Yu Gothic" pitchFamily="34" charset="-120"/>
-              </a:rPr>
-              <a:t>raw / ref / intermediate / marts</a:t>
-            </a:r>
-            <a:endParaRPr lang="en-US" sz="1000" dirty="0"/>
-          </a:p>
-          <a:p>
-            <a:pPr algn="ctr" indent="0" marL="0">
-              <a:lnSpc>
-                <a:spcPts val="1400"/>
-              </a:lnSpc>
-              <a:buNone/>
-            </a:pPr>
-            <a:r>
-              <a:rPr lang="en-US" sz="1000" dirty="0">
-                <a:solidFill>
-                  <a:srgbClr val="CADCFC"/>
-                </a:solidFill>
-                <a:latin typeface="Yu Gothic" pitchFamily="34" charset="0"/>
-                <a:ea typeface="Yu Gothic" pitchFamily="34" charset="-122"/>
-                <a:cs typeface="Yu Gothic" pitchFamily="34" charset="-120"/>
-              </a:rPr>
-              <a:t>166 MB・単一ファイル</a:t>
-            </a:r>
-            <a:endParaRPr lang="en-US" sz="1000" dirty="0"/>
-          </a:p>
-        </p:txBody>
-      </p:sp>
-      <p:sp>
-        <p:nvSpPr>
-          <p:cNvPr id="20" name="Shape 18"/>
+              <a:rPr lang="en-US" sz="950" dirty="0">
+                <a:solidFill>
+                  <a:srgbClr val="DCE2EA"/>
+                </a:solidFill>
+                <a:latin typeface="Yu Gothic" pitchFamily="34" charset="0"/>
+                <a:ea typeface="Yu Gothic" pitchFamily="34" charset="-122"/>
+                <a:cs typeface="Yu Gothic" pitchFamily="34" charset="-120"/>
+              </a:rPr>
+              <a:t>型変換・列名統一 ／ 2 シート重複（2010-12-01〜09, 22,523 行）を除去</a:t>
+            </a:r>
+            <a:endParaRPr lang="en-US" sz="950" dirty="0"/>
+          </a:p>
+        </p:txBody>
+      </p:sp>
+      <p:sp>
+        <p:nvSpPr>
+          <p:cNvPr id="22" name="Shape 20"/>
           <p:cNvSpPr/>
           <p:nvPr/>
         </p:nvSpPr>
         <p:spPr>
           <a:xfrm>
-            <a:off x="9386316" y="2308860"/>
-            <a:ext cx="192024" cy="182880"/>
+            <a:off x="5055108" y="3140964"/>
+            <a:ext cx="173736" cy="164592"/>
           </a:xfrm>
           <a:prstGeom prst="rightArrow">
             <a:avLst/>
           </a:prstGeom>
           <a:solidFill>
-            <a:srgbClr val="8FB3E8"/>
+            <a:srgbClr val="AEBACB"/>
           </a:solidFill>
           <a:ln/>
         </p:spPr>
       </p:sp>
       <p:sp>
         <p:nvSpPr>
-          <p:cNvPr id="21" name="Shape 19"/>
+          <p:cNvPr id="23" name="Shape 21"/>
           <p:cNvSpPr/>
           <p:nvPr/>
         </p:nvSpPr>
         <p:spPr>
           <a:xfrm>
-            <a:off x="9619488" y="1783080"/>
-            <a:ext cx="1993392" cy="1234440"/>
+            <a:off x="5260848" y="2697480"/>
+            <a:ext cx="3057144" cy="1051560"/>
           </a:xfrm>
           <a:prstGeom prst="roundRect">
             <a:avLst>
-              <a:gd name="adj" fmla="val 5926"/>
+              <a:gd name="adj" fmla="val 6957"/>
             </a:avLst>
           </a:prstGeom>
           <a:solidFill>
-            <a:srgbClr val="2E3C7A"/>
+            <a:srgbClr val="556175"/>
           </a:solidFill>
           <a:ln/>
         </p:spPr>
       </p:sp>
       <p:sp>
         <p:nvSpPr>
-          <p:cNvPr id="22" name="Text 20"/>
-          <p:cNvSpPr txBox="1"/>
-          <p:nvPr/>
-        </p:nvSpPr>
-        <p:spPr>
-          <a:xfrm>
-            <a:off x="9729216" y="1929384"/>
-            <a:ext cx="1773936" cy="274320"/>
-          </a:xfrm>
-          <a:prstGeom prst="rect">
-            <a:avLst/>
-          </a:prstGeom>
-          <a:noFill/>
-          <a:ln/>
-        </p:spPr>
-        <p:txBody>
-          <a:bodyPr wrap="square" lIns="0" tIns="0" rIns="0" bIns="0" rtlCol="0" anchor="ctr"/>
-          <a:lstStyle/>
-          <a:p>
-            <a:pPr algn="ctr" indent="0" marL="0">
-              <a:buNone/>
-            </a:pPr>
-            <a:r>
-              <a:rPr lang="en-US" sz="1200" b="1" dirty="0">
+          <p:cNvPr id="24" name="Text 22"/>
+          <p:cNvSpPr txBox="1"/>
+          <p:nvPr/>
+        </p:nvSpPr>
+        <p:spPr>
+          <a:xfrm>
+            <a:off x="5407152" y="2816352"/>
+            <a:ext cx="2764536" cy="237744"/>
+          </a:xfrm>
+          <a:prstGeom prst="rect">
+            <a:avLst/>
+          </a:prstGeom>
+          <a:noFill/>
+          <a:ln/>
+        </p:spPr>
+        <p:txBody>
+          <a:bodyPr wrap="square" lIns="0" tIns="0" rIns="0" bIns="0" rtlCol="0" anchor="ctr"/>
+          <a:lstStyle/>
+          <a:p>
+            <a:pPr indent="0" marL="0">
+              <a:buNone/>
+            </a:pPr>
+            <a:r>
+              <a:rPr lang="en-US" sz="1150" b="1" dirty="0">
                 <a:solidFill>
                   <a:srgbClr val="FFFFFF"/>
                 </a:solidFill>
@@ -2064,122 +2062,323 @@
                 <a:ea typeface="Yu Gothic" pitchFamily="34" charset="-122"/>
                 <a:cs typeface="Yu Gothic" pitchFamily="34" charset="-120"/>
               </a:rPr>
-              <a:t>Streamlit / AI</a:t>
-            </a:r>
-            <a:endParaRPr lang="en-US" sz="1200" dirty="0"/>
-          </a:p>
-        </p:txBody>
-      </p:sp>
-      <p:sp>
-        <p:nvSpPr>
-          <p:cNvPr id="23" name="Text 21"/>
-          <p:cNvSpPr txBox="1"/>
-          <p:nvPr/>
-        </p:nvSpPr>
-        <p:spPr>
-          <a:xfrm>
-            <a:off x="9710928" y="2240280"/>
-            <a:ext cx="1810512" cy="667512"/>
-          </a:xfrm>
-          <a:prstGeom prst="rect">
-            <a:avLst/>
-          </a:prstGeom>
-          <a:noFill/>
-          <a:ln/>
-        </p:spPr>
-        <p:txBody>
-          <a:bodyPr wrap="square" lIns="0" tIns="0" rIns="0" bIns="0" rtlCol="0" anchor="ctr"/>
-          <a:lstStyle/>
-          <a:p>
-            <a:pPr algn="ctr" indent="0" marL="0">
+              <a:t>intermediate</a:t>
+            </a:r>
+            <a:endParaRPr lang="en-US" sz="1150" dirty="0"/>
+          </a:p>
+        </p:txBody>
+      </p:sp>
+      <p:sp>
+        <p:nvSpPr>
+          <p:cNvPr id="25" name="Text 23"/>
+          <p:cNvSpPr txBox="1"/>
+          <p:nvPr/>
+        </p:nvSpPr>
+        <p:spPr>
+          <a:xfrm>
+            <a:off x="5407152" y="3081528"/>
+            <a:ext cx="2764536" cy="576072"/>
+          </a:xfrm>
+          <a:prstGeom prst="rect">
+            <a:avLst/>
+          </a:prstGeom>
+          <a:noFill/>
+          <a:ln/>
+        </p:spPr>
+        <p:txBody>
+          <a:bodyPr wrap="square" lIns="0" tIns="0" rIns="0" bIns="0" rtlCol="0" anchor="ctr"/>
+          <a:lstStyle/>
+          <a:p>
+            <a:pPr indent="0" marL="0">
               <a:lnSpc>
-                <a:spcPts val="1400"/>
+                <a:spcPts val="1300"/>
               </a:lnSpc>
               <a:buNone/>
             </a:pPr>
             <a:r>
-              <a:rPr lang="en-US" sz="1000" dirty="0">
-                <a:solidFill>
-                  <a:srgbClr val="CADCFC"/>
-                </a:solidFill>
-                <a:latin typeface="Yu Gothic" pitchFamily="34" charset="0"/>
-                <a:ea typeface="Yu Gothic" pitchFamily="34" charset="-122"/>
-                <a:cs typeface="Yu Gothic" pitchFamily="34" charset="-120"/>
-              </a:rPr>
-              <a:t>ダッシュボード</a:t>
-            </a:r>
-            <a:endParaRPr lang="en-US" sz="1000" dirty="0"/>
-          </a:p>
-          <a:p>
-            <a:pPr algn="ctr" indent="0" marL="0">
-              <a:lnSpc>
-                <a:spcPts val="1400"/>
-              </a:lnSpc>
-              <a:buNone/>
-            </a:pPr>
-            <a:r>
-              <a:rPr lang="en-US" sz="1000" dirty="0">
-                <a:solidFill>
-                  <a:srgbClr val="CADCFC"/>
-                </a:solidFill>
-                <a:latin typeface="Yu Gothic" pitchFamily="34" charset="0"/>
-                <a:ea typeface="Yu Gothic" pitchFamily="34" charset="-122"/>
-                <a:cs typeface="Yu Gothic" pitchFamily="34" charset="-120"/>
-              </a:rPr>
-              <a:t>自然言語アシスタント</a:t>
-            </a:r>
-            <a:endParaRPr lang="en-US" sz="1000" dirty="0"/>
-          </a:p>
-        </p:txBody>
-      </p:sp>
-      <p:sp>
-        <p:nvSpPr>
-          <p:cNvPr id="24" name="Shape 22"/>
+              <a:rPr lang="en-US" sz="950" dirty="0">
+                <a:solidFill>
+                  <a:srgbClr val="DCE2EA"/>
+                </a:solidFill>
+                <a:latin typeface="Yu Gothic" pitchFamily="34" charset="0"/>
+                <a:ea typeface="Yu Gothic" pitchFamily="34" charset="-122"/>
+                <a:cs typeface="Yu Gothic" pitchFamily="34" charset="-120"/>
+              </a:rPr>
+              <a:t>除外理由を付けて保持 → 商品 × 価格チャネル × 期間の単価を算出</a:t>
+            </a:r>
+            <a:endParaRPr lang="en-US" sz="950" dirty="0"/>
+          </a:p>
+        </p:txBody>
+      </p:sp>
+      <p:sp>
+        <p:nvSpPr>
+          <p:cNvPr id="26" name="Shape 24"/>
           <p:cNvSpPr/>
           <p:nvPr/>
         </p:nvSpPr>
         <p:spPr>
           <a:xfrm>
-            <a:off x="548640" y="3337560"/>
-            <a:ext cx="3584448" cy="2286000"/>
+            <a:off x="8349996" y="3140964"/>
+            <a:ext cx="173736" cy="164592"/>
+          </a:xfrm>
+          <a:prstGeom prst="rightArrow">
+            <a:avLst/>
+          </a:prstGeom>
+          <a:solidFill>
+            <a:srgbClr val="AEBACB"/>
+          </a:solidFill>
+          <a:ln/>
+        </p:spPr>
+      </p:sp>
+      <p:sp>
+        <p:nvSpPr>
+          <p:cNvPr id="27" name="Shape 25"/>
+          <p:cNvSpPr/>
+          <p:nvPr/>
+        </p:nvSpPr>
+        <p:spPr>
+          <a:xfrm>
+            <a:off x="8555736" y="2697480"/>
+            <a:ext cx="3057144" cy="1051560"/>
           </a:xfrm>
           <a:prstGeom prst="roundRect">
             <a:avLst>
-              <a:gd name="adj" fmla="val 3200"/>
+              <a:gd name="adj" fmla="val 6957"/>
             </a:avLst>
           </a:prstGeom>
           <a:solidFill>
-            <a:srgbClr val="2E3C7A"/>
+            <a:srgbClr val="DCE2EA"/>
           </a:solidFill>
           <a:ln/>
         </p:spPr>
       </p:sp>
       <p:sp>
         <p:nvSpPr>
-          <p:cNvPr id="25" name="Text 23"/>
-          <p:cNvSpPr txBox="1"/>
-          <p:nvPr/>
-        </p:nvSpPr>
-        <p:spPr>
-          <a:xfrm>
-            <a:off x="768096" y="3520440"/>
-            <a:ext cx="3145536" cy="274320"/>
-          </a:xfrm>
-          <a:prstGeom prst="rect">
-            <a:avLst/>
-          </a:prstGeom>
-          <a:noFill/>
-          <a:ln/>
-        </p:spPr>
-        <p:txBody>
-          <a:bodyPr wrap="square" lIns="0" tIns="0" rIns="0" bIns="0" rtlCol="0" anchor="ctr"/>
-          <a:lstStyle/>
-          <a:p>
-            <a:pPr indent="0" marL="0">
-              <a:buNone/>
-            </a:pPr>
-            <a:r>
-              <a:rPr lang="en-US" sz="1400" b="1" dirty="0">
+          <p:cNvPr id="28" name="Text 26"/>
+          <p:cNvSpPr txBox="1"/>
+          <p:nvPr/>
+        </p:nvSpPr>
+        <p:spPr>
+          <a:xfrm>
+            <a:off x="8702040" y="2816352"/>
+            <a:ext cx="2764536" cy="237744"/>
+          </a:xfrm>
+          <a:prstGeom prst="rect">
+            <a:avLst/>
+          </a:prstGeom>
+          <a:noFill/>
+          <a:ln/>
+        </p:spPr>
+        <p:txBody>
+          <a:bodyPr wrap="square" lIns="0" tIns="0" rIns="0" bIns="0" rtlCol="0" anchor="ctr"/>
+          <a:lstStyle/>
+          <a:p>
+            <a:pPr indent="0" marL="0">
+              <a:buNone/>
+            </a:pPr>
+            <a:r>
+              <a:rPr lang="en-US" sz="1150" b="1" dirty="0">
+                <a:solidFill>
+                  <a:srgbClr val="434E60"/>
+                </a:solidFill>
+                <a:latin typeface="Yu Gothic" pitchFamily="34" charset="0"/>
+                <a:ea typeface="Yu Gothic" pitchFamily="34" charset="-122"/>
+                <a:cs typeface="Yu Gothic" pitchFamily="34" charset="-120"/>
+              </a:rPr>
+              <a:t>marts</a:t>
+            </a:r>
+            <a:endParaRPr lang="en-US" sz="1150" dirty="0"/>
+          </a:p>
+        </p:txBody>
+      </p:sp>
+      <p:sp>
+        <p:nvSpPr>
+          <p:cNvPr id="29" name="Text 27"/>
+          <p:cNvSpPr txBox="1"/>
+          <p:nvPr/>
+        </p:nvSpPr>
+        <p:spPr>
+          <a:xfrm>
+            <a:off x="8702040" y="3081528"/>
+            <a:ext cx="2764536" cy="576072"/>
+          </a:xfrm>
+          <a:prstGeom prst="rect">
+            <a:avLst/>
+          </a:prstGeom>
+          <a:noFill/>
+          <a:ln/>
+        </p:spPr>
+        <p:txBody>
+          <a:bodyPr wrap="square" lIns="0" tIns="0" rIns="0" bIns="0" rtlCol="0" anchor="ctr"/>
+          <a:lstStyle/>
+          <a:p>
+            <a:pPr indent="0" marL="0">
+              <a:lnSpc>
+                <a:spcPts val="1300"/>
+              </a:lnSpc>
+              <a:buNone/>
+            </a:pPr>
+            <a:r>
+              <a:rPr lang="en-US" sz="950" dirty="0">
+                <a:solidFill>
+                  <a:srgbClr val="434E60"/>
+                </a:solidFill>
+                <a:latin typeface="Yu Gothic" pitchFamily="34" charset="0"/>
+                <a:ea typeface="Yu Gothic" pitchFamily="34" charset="-122"/>
+                <a:cs typeface="Yu Gothic" pitchFamily="34" charset="-120"/>
+              </a:rPr>
+              <a:t>物価指数（日次・月次・カテゴリ別）／ 寄与度 ／ 売上 ／ データ品質</a:t>
+            </a:r>
+            <a:endParaRPr lang="en-US" sz="950" dirty="0"/>
+          </a:p>
+        </p:txBody>
+      </p:sp>
+      <p:sp>
+        <p:nvSpPr>
+          <p:cNvPr id="30" name="Shape 28"/>
+          <p:cNvSpPr/>
+          <p:nvPr/>
+        </p:nvSpPr>
+        <p:spPr>
+          <a:xfrm>
+            <a:off x="6583680" y="3886200"/>
+            <a:ext cx="164592" cy="237744"/>
+          </a:xfrm>
+          <a:prstGeom prst="downArrow">
+            <a:avLst/>
+          </a:prstGeom>
+          <a:solidFill>
+            <a:srgbClr val="AEBACB"/>
+          </a:solidFill>
+          <a:ln/>
+        </p:spPr>
+      </p:sp>
+      <p:sp>
+        <p:nvSpPr>
+          <p:cNvPr id="31" name="Text 29"/>
+          <p:cNvSpPr txBox="1"/>
+          <p:nvPr/>
+        </p:nvSpPr>
+        <p:spPr>
+          <a:xfrm>
+            <a:off x="6949440" y="3867912"/>
+            <a:ext cx="4663440" cy="274320"/>
+          </a:xfrm>
+          <a:prstGeom prst="rect">
+            <a:avLst/>
+          </a:prstGeom>
+          <a:noFill/>
+          <a:ln/>
+        </p:spPr>
+        <p:txBody>
+          <a:bodyPr wrap="square" lIns="0" tIns="0" rIns="0" bIns="0" rtlCol="0" anchor="ctr"/>
+          <a:lstStyle/>
+          <a:p>
+            <a:pPr indent="0" marL="0">
+              <a:buNone/>
+            </a:pPr>
+            <a:r>
+              <a:rPr lang="en-US" sz="950" dirty="0">
+                <a:solidFill>
+                  <a:srgbClr val="AEBACB"/>
+                </a:solidFill>
+                <a:latin typeface="Yu Gothic" pitchFamily="34" charset="0"/>
+                <a:ea typeface="Yu Gothic" pitchFamily="34" charset="-122"/>
+                <a:cs typeface="Yu Gothic" pitchFamily="34" charset="-120"/>
+              </a:rPr>
+              <a:t>28 件の dbt テスト（一般・恒等式・意味層との整合）が全モデルに紐づく</a:t>
+            </a:r>
+            <a:endParaRPr lang="en-US" sz="950" dirty="0"/>
+          </a:p>
+        </p:txBody>
+      </p:sp>
+      <p:sp>
+        <p:nvSpPr>
+          <p:cNvPr id="32" name="Text 30"/>
+          <p:cNvSpPr txBox="1"/>
+          <p:nvPr/>
+        </p:nvSpPr>
+        <p:spPr>
+          <a:xfrm>
+            <a:off x="548640" y="4631436"/>
+            <a:ext cx="1371600" cy="292608"/>
+          </a:xfrm>
+          <a:prstGeom prst="rect">
+            <a:avLst/>
+          </a:prstGeom>
+          <a:noFill/>
+          <a:ln/>
+        </p:spPr>
+        <p:txBody>
+          <a:bodyPr wrap="square" lIns="0" tIns="0" rIns="0" bIns="0" rtlCol="0" anchor="ctr"/>
+          <a:lstStyle/>
+          <a:p>
+            <a:pPr indent="0" marL="0">
+              <a:buNone/>
+            </a:pPr>
+            <a:r>
+              <a:rPr lang="en-US" sz="1150" b="1" dirty="0">
+                <a:solidFill>
+                  <a:srgbClr val="AEBACB"/>
+                </a:solidFill>
+                <a:latin typeface="Yu Gothic" pitchFamily="34" charset="0"/>
+                <a:ea typeface="Yu Gothic" pitchFamily="34" charset="-122"/>
+                <a:cs typeface="Yu Gothic" pitchFamily="34" charset="-120"/>
+              </a:rPr>
+              <a:t>③ 出力</a:t>
+            </a:r>
+            <a:endParaRPr lang="en-US" sz="1150" dirty="0"/>
+          </a:p>
+        </p:txBody>
+      </p:sp>
+      <p:sp>
+        <p:nvSpPr>
+          <p:cNvPr id="33" name="Shape 31"/>
+          <p:cNvSpPr/>
+          <p:nvPr/>
+        </p:nvSpPr>
+        <p:spPr>
+          <a:xfrm>
+            <a:off x="1965960" y="4251960"/>
+            <a:ext cx="4704588" cy="1051560"/>
+          </a:xfrm>
+          <a:prstGeom prst="roundRect">
+            <a:avLst>
+              <a:gd name="adj" fmla="val 6957"/>
+            </a:avLst>
+          </a:prstGeom>
+          <a:solidFill>
+            <a:srgbClr val="556175"/>
+          </a:solidFill>
+          <a:ln/>
+        </p:spPr>
+      </p:sp>
+      <p:sp>
+        <p:nvSpPr>
+          <p:cNvPr id="34" name="Text 32"/>
+          <p:cNvSpPr txBox="1"/>
+          <p:nvPr/>
+        </p:nvSpPr>
+        <p:spPr>
+          <a:xfrm>
+            <a:off x="2112264" y="4370832"/>
+            <a:ext cx="4411980" cy="237744"/>
+          </a:xfrm>
+          <a:prstGeom prst="rect">
+            <a:avLst/>
+          </a:prstGeom>
+          <a:noFill/>
+          <a:ln/>
+        </p:spPr>
+        <p:txBody>
+          <a:bodyPr wrap="square" lIns="0" tIns="0" rIns="0" bIns="0" rtlCol="0" anchor="ctr"/>
+          <a:lstStyle/>
+          <a:p>
+            <a:pPr indent="0" marL="0">
+              <a:buNone/>
+            </a:pPr>
+            <a:r>
+              <a:rPr lang="en-US" sz="1150" b="1" dirty="0">
                 <a:solidFill>
                   <a:srgbClr val="FFFFFF"/>
                 </a:solidFill>
@@ -2187,22 +2386,206 @@
                 <a:ea typeface="Yu Gothic" pitchFamily="34" charset="-122"/>
                 <a:cs typeface="Yu Gothic" pitchFamily="34" charset="-120"/>
               </a:rPr>
-              <a:t>DuckDB</a:t>
-            </a:r>
-            <a:endParaRPr lang="en-US" sz="1400" dirty="0"/>
-          </a:p>
-        </p:txBody>
-      </p:sp>
-      <p:sp>
-        <p:nvSpPr>
-          <p:cNvPr id="26" name="Text 24"/>
-          <p:cNvSpPr txBox="1"/>
-          <p:nvPr/>
-        </p:nvSpPr>
-        <p:spPr>
-          <a:xfrm>
-            <a:off x="768096" y="3858768"/>
-            <a:ext cx="3145536" cy="1645920"/>
+              <a:t>Streamlit ダッシュボード</a:t>
+            </a:r>
+            <a:endParaRPr lang="en-US" sz="1150" dirty="0"/>
+          </a:p>
+        </p:txBody>
+      </p:sp>
+      <p:sp>
+        <p:nvSpPr>
+          <p:cNvPr id="35" name="Text 33"/>
+          <p:cNvSpPr txBox="1"/>
+          <p:nvPr/>
+        </p:nvSpPr>
+        <p:spPr>
+          <a:xfrm>
+            <a:off x="2112264" y="4636008"/>
+            <a:ext cx="4411980" cy="576072"/>
+          </a:xfrm>
+          <a:prstGeom prst="rect">
+            <a:avLst/>
+          </a:prstGeom>
+          <a:noFill/>
+          <a:ln/>
+        </p:spPr>
+        <p:txBody>
+          <a:bodyPr wrap="square" lIns="0" tIns="0" rIns="0" bIns="0" rtlCol="0" anchor="ctr"/>
+          <a:lstStyle/>
+          <a:p>
+            <a:pPr indent="0" marL="0">
+              <a:lnSpc>
+                <a:spcPts val="1300"/>
+              </a:lnSpc>
+              <a:buNone/>
+            </a:pPr>
+            <a:r>
+              <a:rPr lang="en-US" sz="950" dirty="0">
+                <a:solidFill>
+                  <a:srgbClr val="DCE2EA"/>
+                </a:solidFill>
+                <a:latin typeface="Yu Gothic" pitchFamily="34" charset="0"/>
+                <a:ea typeface="Yu Gothic" pitchFamily="34" charset="-122"/>
+                <a:cs typeface="Yu Gothic" pitchFamily="34" charset="-120"/>
+              </a:rPr>
+              <a:t>物価指数の 3 方式比較 ／ 寄与度 ／ クリーニング内訳 ／ 日次データ量の監視とアラート</a:t>
+            </a:r>
+            <a:endParaRPr lang="en-US" sz="950" dirty="0"/>
+          </a:p>
+        </p:txBody>
+      </p:sp>
+      <p:sp>
+        <p:nvSpPr>
+          <p:cNvPr id="36" name="Shape 34"/>
+          <p:cNvSpPr/>
+          <p:nvPr/>
+        </p:nvSpPr>
+        <p:spPr>
+          <a:xfrm>
+            <a:off x="6908292" y="4251960"/>
+            <a:ext cx="4704588" cy="1051560"/>
+          </a:xfrm>
+          <a:prstGeom prst="roundRect">
+            <a:avLst>
+              <a:gd name="adj" fmla="val 6957"/>
+            </a:avLst>
+          </a:prstGeom>
+          <a:solidFill>
+            <a:srgbClr val="556175"/>
+          </a:solidFill>
+          <a:ln/>
+        </p:spPr>
+      </p:sp>
+      <p:sp>
+        <p:nvSpPr>
+          <p:cNvPr id="37" name="Text 35"/>
+          <p:cNvSpPr txBox="1"/>
+          <p:nvPr/>
+        </p:nvSpPr>
+        <p:spPr>
+          <a:xfrm>
+            <a:off x="7054596" y="4370832"/>
+            <a:ext cx="4411980" cy="237744"/>
+          </a:xfrm>
+          <a:prstGeom prst="rect">
+            <a:avLst/>
+          </a:prstGeom>
+          <a:noFill/>
+          <a:ln/>
+        </p:spPr>
+        <p:txBody>
+          <a:bodyPr wrap="square" lIns="0" tIns="0" rIns="0" bIns="0" rtlCol="0" anchor="ctr"/>
+          <a:lstStyle/>
+          <a:p>
+            <a:pPr indent="0" marL="0">
+              <a:buNone/>
+            </a:pPr>
+            <a:r>
+              <a:rPr lang="en-US" sz="1150" b="1" dirty="0">
+                <a:solidFill>
+                  <a:srgbClr val="FFFFFF"/>
+                </a:solidFill>
+                <a:latin typeface="Yu Gothic" pitchFamily="34" charset="0"/>
+                <a:ea typeface="Yu Gothic" pitchFamily="34" charset="-122"/>
+                <a:cs typeface="Yu Gothic" pitchFamily="34" charset="-120"/>
+              </a:rPr>
+              <a:t>AI アシスタント</a:t>
+            </a:r>
+            <a:endParaRPr lang="en-US" sz="1150" dirty="0"/>
+          </a:p>
+        </p:txBody>
+      </p:sp>
+      <p:sp>
+        <p:nvSpPr>
+          <p:cNvPr id="38" name="Text 36"/>
+          <p:cNvSpPr txBox="1"/>
+          <p:nvPr/>
+        </p:nvSpPr>
+        <p:spPr>
+          <a:xfrm>
+            <a:off x="7054596" y="4636008"/>
+            <a:ext cx="4411980" cy="576072"/>
+          </a:xfrm>
+          <a:prstGeom prst="rect">
+            <a:avLst/>
+          </a:prstGeom>
+          <a:noFill/>
+          <a:ln/>
+        </p:spPr>
+        <p:txBody>
+          <a:bodyPr wrap="square" lIns="0" tIns="0" rIns="0" bIns="0" rtlCol="0" anchor="ctr"/>
+          <a:lstStyle/>
+          <a:p>
+            <a:pPr indent="0" marL="0">
+              <a:lnSpc>
+                <a:spcPts val="1300"/>
+              </a:lnSpc>
+              <a:buNone/>
+            </a:pPr>
+            <a:r>
+              <a:rPr lang="en-US" sz="950" dirty="0">
+                <a:solidFill>
+                  <a:srgbClr val="DCE2EA"/>
+                </a:solidFill>
+                <a:latin typeface="Yu Gothic" pitchFamily="34" charset="0"/>
+                <a:ea typeface="Yu Gothic" pitchFamily="34" charset="-122"/>
+                <a:cs typeface="Yu Gothic" pitchFamily="34" charset="-120"/>
+              </a:rPr>
+              <a:t>意味層 → SQL 生成 → 構文木で検査 → read_only 実行 → 回答の数値を結果と照合</a:t>
+            </a:r>
+            <a:endParaRPr lang="en-US" sz="950" dirty="0"/>
+          </a:p>
+        </p:txBody>
+      </p:sp>
+      <p:sp>
+        <p:nvSpPr>
+          <p:cNvPr id="39" name="Text 37"/>
+          <p:cNvSpPr txBox="1"/>
+          <p:nvPr/>
+        </p:nvSpPr>
+        <p:spPr>
+          <a:xfrm>
+            <a:off x="548640" y="5669280"/>
+            <a:ext cx="1828800" cy="256032"/>
+          </a:xfrm>
+          <a:prstGeom prst="rect">
+            <a:avLst/>
+          </a:prstGeom>
+          <a:noFill/>
+          <a:ln/>
+        </p:spPr>
+        <p:txBody>
+          <a:bodyPr wrap="square" lIns="0" tIns="0" rIns="0" bIns="0" rtlCol="0" anchor="ctr"/>
+          <a:lstStyle/>
+          <a:p>
+            <a:pPr indent="0" marL="0">
+              <a:buNone/>
+            </a:pPr>
+            <a:r>
+              <a:rPr lang="en-US" sz="1150" b="1" dirty="0">
+                <a:solidFill>
+                  <a:srgbClr val="AEBACB"/>
+                </a:solidFill>
+                <a:latin typeface="Yu Gothic" pitchFamily="34" charset="0"/>
+                <a:ea typeface="Yu Gothic" pitchFamily="34" charset="-122"/>
+                <a:cs typeface="Yu Gothic" pitchFamily="34" charset="-120"/>
+              </a:rPr>
+              <a:t>技術スタック</a:t>
+            </a:r>
+            <a:endParaRPr lang="en-US" sz="1150" dirty="0"/>
+          </a:p>
+        </p:txBody>
+      </p:sp>
+      <p:sp>
+        <p:nvSpPr>
+          <p:cNvPr id="40" name="Text 38"/>
+          <p:cNvSpPr txBox="1"/>
+          <p:nvPr/>
+        </p:nvSpPr>
+        <p:spPr>
+          <a:xfrm>
+            <a:off x="1965960" y="5650992"/>
+            <a:ext cx="9646920" cy="548640"/>
           </a:xfrm>
           <a:prstGeom prst="rect">
             <a:avLst/>
@@ -2221,262 +2604,17 @@
               <a:buNone/>
             </a:pPr>
             <a:r>
-              <a:rPr lang="en-US" sz="1050" dirty="0">
-                <a:solidFill>
-                  <a:srgbClr val="CADCFC"/>
-                </a:solidFill>
-                <a:latin typeface="Yu Gothic" pitchFamily="34" charset="0"/>
-                <a:ea typeface="Yu Gothic" pitchFamily="34" charset="-122"/>
-                <a:cs typeface="Yu Gothic" pitchFamily="34" charset="-120"/>
-              </a:rPr>
-              <a:t>ゼロ依存・単一ファイルで、clone 後すぐ再現できる。列指向で 104 万行の集計が 11 ms、全量再構築は 18.5 秒。アシスタントには read_only かつ外部ファイルアクセス無効の接続を渡し、エンジン側の安全境界として使う。</a:t>
-            </a:r>
-            <a:endParaRPr lang="en-US" sz="1050" dirty="0"/>
-          </a:p>
-        </p:txBody>
-      </p:sp>
-      <p:sp>
-        <p:nvSpPr>
-          <p:cNvPr id="27" name="Shape 25"/>
-          <p:cNvSpPr/>
-          <p:nvPr/>
-        </p:nvSpPr>
-        <p:spPr>
-          <a:xfrm>
-            <a:off x="4288536" y="3337560"/>
-            <a:ext cx="3584448" cy="2286000"/>
-          </a:xfrm>
-          <a:prstGeom prst="roundRect">
-            <a:avLst>
-              <a:gd name="adj" fmla="val 3200"/>
-            </a:avLst>
-          </a:prstGeom>
-          <a:solidFill>
-            <a:srgbClr val="2E3C7A"/>
-          </a:solidFill>
-          <a:ln/>
-        </p:spPr>
-      </p:sp>
-      <p:sp>
-        <p:nvSpPr>
-          <p:cNvPr id="28" name="Text 26"/>
-          <p:cNvSpPr txBox="1"/>
-          <p:nvPr/>
-        </p:nvSpPr>
-        <p:spPr>
-          <a:xfrm>
-            <a:off x="4507992" y="3520440"/>
-            <a:ext cx="3145536" cy="274320"/>
-          </a:xfrm>
-          <a:prstGeom prst="rect">
-            <a:avLst/>
-          </a:prstGeom>
-          <a:noFill/>
-          <a:ln/>
-        </p:spPr>
-        <p:txBody>
-          <a:bodyPr wrap="square" lIns="0" tIns="0" rIns="0" bIns="0" rtlCol="0" anchor="ctr"/>
-          <a:lstStyle/>
-          <a:p>
-            <a:pPr indent="0" marL="0">
-              <a:buNone/>
-            </a:pPr>
-            <a:r>
-              <a:rPr lang="en-US" sz="1400" b="1" dirty="0">
-                <a:solidFill>
-                  <a:srgbClr val="FFFFFF"/>
-                </a:solidFill>
-                <a:latin typeface="Yu Gothic" pitchFamily="34" charset="0"/>
-                <a:ea typeface="Yu Gothic" pitchFamily="34" charset="-122"/>
-                <a:cs typeface="Yu Gothic" pitchFamily="34" charset="-120"/>
-              </a:rPr>
-              <a:t>dbt</a:t>
-            </a:r>
-            <a:endParaRPr lang="en-US" sz="1400" dirty="0"/>
-          </a:p>
-        </p:txBody>
-      </p:sp>
-      <p:sp>
-        <p:nvSpPr>
-          <p:cNvPr id="29" name="Text 27"/>
-          <p:cNvSpPr txBox="1"/>
-          <p:nvPr/>
-        </p:nvSpPr>
-        <p:spPr>
-          <a:xfrm>
-            <a:off x="4507992" y="3858768"/>
-            <a:ext cx="3145536" cy="1645920"/>
-          </a:xfrm>
-          <a:prstGeom prst="rect">
-            <a:avLst/>
-          </a:prstGeom>
-          <a:noFill/>
-          <a:ln/>
-        </p:spPr>
-        <p:txBody>
-          <a:bodyPr wrap="square" lIns="0" tIns="0" rIns="0" bIns="0" rtlCol="0" anchor="ctr"/>
-          <a:lstStyle/>
-          <a:p>
-            <a:pPr indent="0" marL="0">
-              <a:lnSpc>
-                <a:spcPts val="1600"/>
-              </a:lnSpc>
-              <a:buNone/>
-            </a:pPr>
-            <a:r>
-              <a:rPr lang="en-US" sz="1050" dirty="0">
-                <a:solidFill>
-                  <a:srgbClr val="CADCFC"/>
-                </a:solidFill>
-                <a:latin typeface="Yu Gothic" pitchFamily="34" charset="0"/>
-                <a:ea typeface="Yu Gothic" pitchFamily="34" charset="-122"/>
-                <a:cs typeface="Yu Gothic" pitchFamily="34" charset="-120"/>
-              </a:rPr>
-              <a:t>ref() で依存 DAG を自動決定。Törnqvist の計算式は macro 1 本にまとめ、日次・月次・カテゴリ別・月接続の 4 モデルで再利用。profiles の target を切り替えれば同じモデルを Snowflake でも実行できる構成（本番未検証）。</a:t>
-            </a:r>
-            <a:endParaRPr lang="en-US" sz="1050" dirty="0"/>
-          </a:p>
-        </p:txBody>
-      </p:sp>
-      <p:sp>
-        <p:nvSpPr>
-          <p:cNvPr id="30" name="Shape 28"/>
-          <p:cNvSpPr/>
-          <p:nvPr/>
-        </p:nvSpPr>
-        <p:spPr>
-          <a:xfrm>
-            <a:off x="8028432" y="3337560"/>
-            <a:ext cx="3584448" cy="2286000"/>
-          </a:xfrm>
-          <a:prstGeom prst="roundRect">
-            <a:avLst>
-              <a:gd name="adj" fmla="val 3200"/>
-            </a:avLst>
-          </a:prstGeom>
-          <a:solidFill>
-            <a:srgbClr val="2E3C7A"/>
-          </a:solidFill>
-          <a:ln/>
-        </p:spPr>
-      </p:sp>
-      <p:sp>
-        <p:nvSpPr>
-          <p:cNvPr id="31" name="Text 29"/>
-          <p:cNvSpPr txBox="1"/>
-          <p:nvPr/>
-        </p:nvSpPr>
-        <p:spPr>
-          <a:xfrm>
-            <a:off x="8247888" y="3520440"/>
-            <a:ext cx="3145536" cy="274320"/>
-          </a:xfrm>
-          <a:prstGeom prst="rect">
-            <a:avLst/>
-          </a:prstGeom>
-          <a:noFill/>
-          <a:ln/>
-        </p:spPr>
-        <p:txBody>
-          <a:bodyPr wrap="square" lIns="0" tIns="0" rIns="0" bIns="0" rtlCol="0" anchor="ctr"/>
-          <a:lstStyle/>
-          <a:p>
-            <a:pPr indent="0" marL="0">
-              <a:buNone/>
-            </a:pPr>
-            <a:r>
-              <a:rPr lang="en-US" sz="1400" b="1" dirty="0">
-                <a:solidFill>
-                  <a:srgbClr val="FFFFFF"/>
-                </a:solidFill>
-                <a:latin typeface="Yu Gothic" pitchFamily="34" charset="0"/>
-                <a:ea typeface="Yu Gothic" pitchFamily="34" charset="-122"/>
-                <a:cs typeface="Yu Gothic" pitchFamily="34" charset="-120"/>
-              </a:rPr>
-              <a:t>LLM は OpenAI 互換 API</a:t>
-            </a:r>
-            <a:endParaRPr lang="en-US" sz="1400" dirty="0"/>
-          </a:p>
-        </p:txBody>
-      </p:sp>
-      <p:sp>
-        <p:nvSpPr>
-          <p:cNvPr id="32" name="Text 30"/>
-          <p:cNvSpPr txBox="1"/>
-          <p:nvPr/>
-        </p:nvSpPr>
-        <p:spPr>
-          <a:xfrm>
-            <a:off x="8247888" y="3858768"/>
-            <a:ext cx="3145536" cy="1645920"/>
-          </a:xfrm>
-          <a:prstGeom prst="rect">
-            <a:avLst/>
-          </a:prstGeom>
-          <a:noFill/>
-          <a:ln/>
-        </p:spPr>
-        <p:txBody>
-          <a:bodyPr wrap="square" lIns="0" tIns="0" rIns="0" bIns="0" rtlCol="0" anchor="ctr"/>
-          <a:lstStyle/>
-          <a:p>
-            <a:pPr indent="0" marL="0">
-              <a:lnSpc>
-                <a:spcPts val="1600"/>
-              </a:lnSpc>
-              <a:buNone/>
-            </a:pPr>
-            <a:r>
-              <a:rPr lang="en-US" sz="1050" dirty="0">
-                <a:solidFill>
-                  <a:srgbClr val="CADCFC"/>
-                </a:solidFill>
-                <a:latin typeface="Yu Gothic" pitchFamily="34" charset="0"/>
-                <a:ea typeface="Yu Gothic" pitchFamily="34" charset="-122"/>
-                <a:cs typeface="Yu Gothic" pitchFamily="34" charset="-120"/>
-              </a:rPr>
-              <a:t>function calling を使わない設計にしたため、provider を選ばない。DeepSeek / OpenAI / ローカル Ollama などを環境変数 3 つで差し替え可能。</a:t>
-            </a:r>
-            <a:endParaRPr lang="en-US" sz="1050" dirty="0"/>
-          </a:p>
-        </p:txBody>
-      </p:sp>
-      <p:sp>
-        <p:nvSpPr>
-          <p:cNvPr id="33" name="Text 31"/>
-          <p:cNvSpPr txBox="1"/>
-          <p:nvPr/>
-        </p:nvSpPr>
-        <p:spPr>
-          <a:xfrm>
-            <a:off x="548640" y="5897880"/>
-            <a:ext cx="11064240" cy="274320"/>
-          </a:xfrm>
-          <a:prstGeom prst="rect">
-            <a:avLst/>
-          </a:prstGeom>
-          <a:noFill/>
-          <a:ln/>
-        </p:spPr>
-        <p:txBody>
-          <a:bodyPr wrap="square" lIns="0" tIns="0" rIns="0" bIns="0" rtlCol="0" anchor="ctr"/>
-          <a:lstStyle/>
-          <a:p>
-            <a:pPr indent="0" marL="0">
-              <a:buNone/>
-            </a:pPr>
-            <a:r>
-              <a:rPr lang="en-US" sz="1050" dirty="0">
-                <a:solidFill>
-                  <a:srgbClr val="8FB3E8"/>
-                </a:solidFill>
-                <a:latin typeface="Yu Gothic" pitchFamily="34" charset="0"/>
-                <a:ea typeface="Yu Gothic" pitchFamily="34" charset="-122"/>
-                <a:cs typeface="Yu Gothic" pitchFamily="34" charset="-120"/>
-              </a:rPr>
-              <a:t>Python 3.12 / uv ・ DuckDB 1.5 ・ dbt 1.12（dbt-duckdb）・ Streamlit ・ sqlglot ・ pytest 26 件</a:t>
-            </a:r>
-            <a:endParaRPr lang="en-US" sz="1050" dirty="0"/>
+              <a:rPr lang="en-US" sz="1000" dirty="0">
+                <a:solidFill>
+                  <a:srgbClr val="DCE2EA"/>
+                </a:solidFill>
+                <a:latin typeface="Yu Gothic" pitchFamily="34" charset="0"/>
+                <a:ea typeface="Yu Gothic" pitchFamily="34" charset="-122"/>
+                <a:cs typeface="Yu Gothic" pitchFamily="34" charset="-120"/>
+              </a:rPr>
+              <a:t>Python 3.12 / uv　・　DuckDB 1.5　・　dbt 1.12（dbt-duckdb, macro / seed / test）　・　Streamlit + Plotly　・　sqlglot（SQL 構文木検査）　・　pytest 26 件　・　OpenAI 互換 LLM API（DeepSeek / OpenAI / Ollama を環境変数で切替）</a:t>
+            </a:r>
+            <a:endParaRPr lang="en-US" sz="1000" dirty="0"/>
           </a:p>
         </p:txBody>
       </p:sp>
@@ -2578,7 +2716,7 @@
             <a:r>
               <a:rPr lang="en-US" sz="2800" b="1" dirty="0">
                 <a:solidFill>
-                  <a:srgbClr val="16203F"/>
+                  <a:srgbClr val="232A36"/>
                 </a:solidFill>
                 <a:latin typeface="Yu Gothic" pitchFamily="34" charset="0"/>
                 <a:ea typeface="Yu Gothic" pitchFamily="34" charset="-122"/>
@@ -2617,7 +2755,7 @@
             <a:r>
               <a:rPr lang="en-US" sz="1150" b="1" dirty="0">
                 <a:solidFill>
-                  <a:srgbClr val="5B6485"/>
+                  <a:srgbClr val="636C7C"/>
                 </a:solidFill>
                 <a:latin typeface="Yu Gothic" pitchFamily="34" charset="0"/>
                 <a:ea typeface="Yu Gothic" pitchFamily="34" charset="-122"/>
@@ -2659,7 +2797,7 @@
             <a:r>
               <a:rPr lang="en-US" sz="1250" dirty="0">
                 <a:solidFill>
-                  <a:srgbClr val="16203F"/>
+                  <a:srgbClr val="232A36"/>
                 </a:solidFill>
                 <a:latin typeface="Yu Gothic" pitchFamily="34" charset="0"/>
                 <a:ea typeface="Yu Gothic" pitchFamily="34" charset="-122"/>
@@ -2698,7 +2836,7 @@
             <a:r>
               <a:rPr lang="en-US" sz="1150" b="1" dirty="0">
                 <a:solidFill>
-                  <a:srgbClr val="5B6485"/>
+                  <a:srgbClr val="636C7C"/>
                 </a:solidFill>
                 <a:latin typeface="Yu Gothic" pitchFamily="34" charset="0"/>
                 <a:ea typeface="Yu Gothic" pitchFamily="34" charset="-122"/>
@@ -2749,7 +2887,7 @@
                       <a:r>
                         <a:rPr lang="en-US" sz="1100" dirty="0">
                           <a:solidFill>
-                            <a:srgbClr val="16203F"/>
+                            <a:srgbClr val="232A36"/>
                           </a:solidFill>
                           <a:latin typeface="Yu Gothic" pitchFamily="34" charset="0"/>
                           <a:ea typeface="Yu Gothic" pitchFamily="34" charset="-122"/>
@@ -2767,7 +2905,7 @@
                   <a:tcPr marL="73152" marR="73152" marT="73152" marB="73152" anchor="ctr">
                     <a:lnL w="12700" cap="flat" cmpd="sng" algn="ctr">
                       <a:solidFill>
-                        <a:srgbClr val="DCE3F5"/>
+                        <a:srgbClr val="DDE2E9"/>
                       </a:solidFill>
                       <a:prstDash val="solid"/>
                       <a:round/>
@@ -2776,7 +2914,7 @@
                     </a:lnL>
                     <a:lnR w="12700" cap="flat" cmpd="sng" algn="ctr">
                       <a:solidFill>
-                        <a:srgbClr val="DCE3F5"/>
+                        <a:srgbClr val="DDE2E9"/>
                       </a:solidFill>
                       <a:prstDash val="solid"/>
                       <a:round/>
@@ -2785,7 +2923,7 @@
                     </a:lnR>
                     <a:lnT w="12700" cap="flat" cmpd="sng" algn="ctr">
                       <a:solidFill>
-                        <a:srgbClr val="DCE3F5"/>
+                        <a:srgbClr val="DDE2E9"/>
                       </a:solidFill>
                       <a:prstDash val="solid"/>
                       <a:round/>
@@ -2794,7 +2932,7 @@
                     </a:lnT>
                     <a:lnB w="12700" cap="flat" cmpd="sng" algn="ctr">
                       <a:solidFill>
-                        <a:srgbClr val="DCE3F5"/>
+                        <a:srgbClr val="DDE2E9"/>
                       </a:solidFill>
                       <a:prstDash val="solid"/>
                       <a:round/>
@@ -2817,7 +2955,7 @@
                       <a:r>
                         <a:rPr lang="en-US" sz="1100" dirty="0">
                           <a:solidFill>
-                            <a:srgbClr val="16203F"/>
+                            <a:srgbClr val="232A36"/>
                           </a:solidFill>
                           <a:latin typeface="Yu Gothic" pitchFamily="34" charset="0"/>
                           <a:ea typeface="Yu Gothic" pitchFamily="34" charset="-122"/>
@@ -2835,7 +2973,7 @@
                   <a:tcPr marL="73152" marR="73152" marT="73152" marB="73152" anchor="ctr">
                     <a:lnL w="12700" cap="flat" cmpd="sng" algn="ctr">
                       <a:solidFill>
-                        <a:srgbClr val="DCE3F5"/>
+                        <a:srgbClr val="DDE2E9"/>
                       </a:solidFill>
                       <a:prstDash val="solid"/>
                       <a:round/>
@@ -2844,7 +2982,7 @@
                     </a:lnL>
                     <a:lnR w="12700" cap="flat" cmpd="sng" algn="ctr">
                       <a:solidFill>
-                        <a:srgbClr val="DCE3F5"/>
+                        <a:srgbClr val="DDE2E9"/>
                       </a:solidFill>
                       <a:prstDash val="solid"/>
                       <a:round/>
@@ -2853,7 +2991,7 @@
                     </a:lnR>
                     <a:lnT w="12700" cap="flat" cmpd="sng" algn="ctr">
                       <a:solidFill>
-                        <a:srgbClr val="DCE3F5"/>
+                        <a:srgbClr val="DDE2E9"/>
                       </a:solidFill>
                       <a:prstDash val="solid"/>
                       <a:round/>
@@ -2862,7 +3000,7 @@
                     </a:lnT>
                     <a:lnB w="12700" cap="flat" cmpd="sng" algn="ctr">
                       <a:solidFill>
-                        <a:srgbClr val="DCE3F5"/>
+                        <a:srgbClr val="DDE2E9"/>
                       </a:solidFill>
                       <a:prstDash val="solid"/>
                       <a:round/>
@@ -2885,7 +3023,7 @@
                       <a:r>
                         <a:rPr lang="en-US" sz="1100" dirty="0">
                           <a:solidFill>
-                            <a:srgbClr val="16203F"/>
+                            <a:srgbClr val="232A36"/>
                           </a:solidFill>
                           <a:latin typeface="Yu Gothic" pitchFamily="34" charset="0"/>
                           <a:ea typeface="Yu Gothic" pitchFamily="34" charset="-122"/>
@@ -2903,7 +3041,7 @@
                   <a:tcPr marL="73152" marR="73152" marT="73152" marB="73152" anchor="ctr">
                     <a:lnL w="12700" cap="flat" cmpd="sng" algn="ctr">
                       <a:solidFill>
-                        <a:srgbClr val="DCE3F5"/>
+                        <a:srgbClr val="DDE2E9"/>
                       </a:solidFill>
                       <a:prstDash val="solid"/>
                       <a:round/>
@@ -2912,7 +3050,7 @@
                     </a:lnL>
                     <a:lnR w="12700" cap="flat" cmpd="sng" algn="ctr">
                       <a:solidFill>
-                        <a:srgbClr val="DCE3F5"/>
+                        <a:srgbClr val="DDE2E9"/>
                       </a:solidFill>
                       <a:prstDash val="solid"/>
                       <a:round/>
@@ -2921,7 +3059,7 @@
                     </a:lnR>
                     <a:lnT w="12700" cap="flat" cmpd="sng" algn="ctr">
                       <a:solidFill>
-                        <a:srgbClr val="DCE3F5"/>
+                        <a:srgbClr val="DDE2E9"/>
                       </a:solidFill>
                       <a:prstDash val="solid"/>
                       <a:round/>
@@ -2930,7 +3068,7 @@
                     </a:lnT>
                     <a:lnB w="12700" cap="flat" cmpd="sng" algn="ctr">
                       <a:solidFill>
-                        <a:srgbClr val="DCE3F5"/>
+                        <a:srgbClr val="DDE2E9"/>
                       </a:solidFill>
                       <a:prstDash val="solid"/>
                       <a:round/>
@@ -2955,7 +3093,7 @@
                       <a:r>
                         <a:rPr lang="en-US" sz="1100" dirty="0">
                           <a:solidFill>
-                            <a:srgbClr val="16203F"/>
+                            <a:srgbClr val="232A36"/>
                           </a:solidFill>
                           <a:latin typeface="Yu Gothic" pitchFamily="34" charset="0"/>
                           <a:ea typeface="Yu Gothic" pitchFamily="34" charset="-122"/>
@@ -2973,7 +3111,7 @@
                   <a:tcPr marL="73152" marR="73152" marT="73152" marB="73152" anchor="ctr">
                     <a:lnL w="12700" cap="flat" cmpd="sng" algn="ctr">
                       <a:solidFill>
-                        <a:srgbClr val="DCE3F5"/>
+                        <a:srgbClr val="DDE2E9"/>
                       </a:solidFill>
                       <a:prstDash val="solid"/>
                       <a:round/>
@@ -2982,7 +3120,7 @@
                     </a:lnL>
                     <a:lnR w="12700" cap="flat" cmpd="sng" algn="ctr">
                       <a:solidFill>
-                        <a:srgbClr val="DCE3F5"/>
+                        <a:srgbClr val="DDE2E9"/>
                       </a:solidFill>
                       <a:prstDash val="solid"/>
                       <a:round/>
@@ -2991,7 +3129,7 @@
                     </a:lnR>
                     <a:lnT w="12700" cap="flat" cmpd="sng" algn="ctr">
                       <a:solidFill>
-                        <a:srgbClr val="DCE3F5"/>
+                        <a:srgbClr val="DDE2E9"/>
                       </a:solidFill>
                       <a:prstDash val="solid"/>
                       <a:round/>
@@ -3000,7 +3138,7 @@
                     </a:lnT>
                     <a:lnB w="12700" cap="flat" cmpd="sng" algn="ctr">
                       <a:solidFill>
-                        <a:srgbClr val="DCE3F5"/>
+                        <a:srgbClr val="DDE2E9"/>
                       </a:solidFill>
                       <a:prstDash val="solid"/>
                       <a:round/>
@@ -3023,7 +3161,7 @@
                       <a:r>
                         <a:rPr lang="en-US" sz="1100" dirty="0">
                           <a:solidFill>
-                            <a:srgbClr val="16203F"/>
+                            <a:srgbClr val="232A36"/>
                           </a:solidFill>
                           <a:latin typeface="Yu Gothic" pitchFamily="34" charset="0"/>
                           <a:ea typeface="Yu Gothic" pitchFamily="34" charset="-122"/>
@@ -3041,7 +3179,7 @@
                   <a:tcPr marL="73152" marR="73152" marT="73152" marB="73152" anchor="ctr">
                     <a:lnL w="12700" cap="flat" cmpd="sng" algn="ctr">
                       <a:solidFill>
-                        <a:srgbClr val="DCE3F5"/>
+                        <a:srgbClr val="DDE2E9"/>
                       </a:solidFill>
                       <a:prstDash val="solid"/>
                       <a:round/>
@@ -3050,7 +3188,7 @@
                     </a:lnL>
                     <a:lnR w="12700" cap="flat" cmpd="sng" algn="ctr">
                       <a:solidFill>
-                        <a:srgbClr val="DCE3F5"/>
+                        <a:srgbClr val="DDE2E9"/>
                       </a:solidFill>
                       <a:prstDash val="solid"/>
                       <a:round/>
@@ -3059,7 +3197,7 @@
                     </a:lnR>
                     <a:lnT w="12700" cap="flat" cmpd="sng" algn="ctr">
                       <a:solidFill>
-                        <a:srgbClr val="DCE3F5"/>
+                        <a:srgbClr val="DDE2E9"/>
                       </a:solidFill>
                       <a:prstDash val="solid"/>
                       <a:round/>
@@ -3068,7 +3206,7 @@
                     </a:lnT>
                     <a:lnB w="12700" cap="flat" cmpd="sng" algn="ctr">
                       <a:solidFill>
-                        <a:srgbClr val="DCE3F5"/>
+                        <a:srgbClr val="DDE2E9"/>
                       </a:solidFill>
                       <a:prstDash val="solid"/>
                       <a:round/>
@@ -3091,7 +3229,7 @@
                       <a:r>
                         <a:rPr lang="en-US" sz="1100" dirty="0">
                           <a:solidFill>
-                            <a:srgbClr val="16203F"/>
+                            <a:srgbClr val="232A36"/>
                           </a:solidFill>
                           <a:latin typeface="Yu Gothic" pitchFamily="34" charset="0"/>
                           <a:ea typeface="Yu Gothic" pitchFamily="34" charset="-122"/>
@@ -3109,7 +3247,7 @@
                   <a:tcPr marL="73152" marR="73152" marT="73152" marB="73152" anchor="ctr">
                     <a:lnL w="12700" cap="flat" cmpd="sng" algn="ctr">
                       <a:solidFill>
-                        <a:srgbClr val="DCE3F5"/>
+                        <a:srgbClr val="DDE2E9"/>
                       </a:solidFill>
                       <a:prstDash val="solid"/>
                       <a:round/>
@@ -3118,7 +3256,7 @@
                     </a:lnL>
                     <a:lnR w="12700" cap="flat" cmpd="sng" algn="ctr">
                       <a:solidFill>
-                        <a:srgbClr val="DCE3F5"/>
+                        <a:srgbClr val="DDE2E9"/>
                       </a:solidFill>
                       <a:prstDash val="solid"/>
                       <a:round/>
@@ -3127,7 +3265,7 @@
                     </a:lnR>
                     <a:lnT w="12700" cap="flat" cmpd="sng" algn="ctr">
                       <a:solidFill>
-                        <a:srgbClr val="DCE3F5"/>
+                        <a:srgbClr val="DDE2E9"/>
                       </a:solidFill>
                       <a:prstDash val="solid"/>
                       <a:round/>
@@ -3136,7 +3274,7 @@
                     </a:lnT>
                     <a:lnB w="12700" cap="flat" cmpd="sng" algn="ctr">
                       <a:solidFill>
-                        <a:srgbClr val="DCE3F5"/>
+                        <a:srgbClr val="DDE2E9"/>
                       </a:solidFill>
                       <a:prstDash val="solid"/>
                       <a:round/>
@@ -3161,7 +3299,7 @@
                       <a:r>
                         <a:rPr lang="en-US" sz="1100" dirty="0">
                           <a:solidFill>
-                            <a:srgbClr val="16203F"/>
+                            <a:srgbClr val="232A36"/>
                           </a:solidFill>
                           <a:latin typeface="Yu Gothic" pitchFamily="34" charset="0"/>
                           <a:ea typeface="Yu Gothic" pitchFamily="34" charset="-122"/>
@@ -3179,7 +3317,7 @@
                   <a:tcPr marL="73152" marR="73152" marT="73152" marB="73152" anchor="ctr">
                     <a:lnL w="12700" cap="flat" cmpd="sng" algn="ctr">
                       <a:solidFill>
-                        <a:srgbClr val="DCE3F5"/>
+                        <a:srgbClr val="DDE2E9"/>
                       </a:solidFill>
                       <a:prstDash val="solid"/>
                       <a:round/>
@@ -3188,7 +3326,7 @@
                     </a:lnL>
                     <a:lnR w="12700" cap="flat" cmpd="sng" algn="ctr">
                       <a:solidFill>
-                        <a:srgbClr val="DCE3F5"/>
+                        <a:srgbClr val="DDE2E9"/>
                       </a:solidFill>
                       <a:prstDash val="solid"/>
                       <a:round/>
@@ -3197,7 +3335,7 @@
                     </a:lnR>
                     <a:lnT w="12700" cap="flat" cmpd="sng" algn="ctr">
                       <a:solidFill>
-                        <a:srgbClr val="DCE3F5"/>
+                        <a:srgbClr val="DDE2E9"/>
                       </a:solidFill>
                       <a:prstDash val="solid"/>
                       <a:round/>
@@ -3206,7 +3344,7 @@
                     </a:lnT>
                     <a:lnB w="12700" cap="flat" cmpd="sng" algn="ctr">
                       <a:solidFill>
-                        <a:srgbClr val="DCE3F5"/>
+                        <a:srgbClr val="DDE2E9"/>
                       </a:solidFill>
                       <a:prstDash val="solid"/>
                       <a:round/>
@@ -3229,7 +3367,7 @@
                       <a:r>
                         <a:rPr lang="en-US" sz="1100" dirty="0">
                           <a:solidFill>
-                            <a:srgbClr val="16203F"/>
+                            <a:srgbClr val="232A36"/>
                           </a:solidFill>
                           <a:latin typeface="Yu Gothic" pitchFamily="34" charset="0"/>
                           <a:ea typeface="Yu Gothic" pitchFamily="34" charset="-122"/>
@@ -3247,7 +3385,7 @@
                   <a:tcPr marL="73152" marR="73152" marT="73152" marB="73152" anchor="ctr">
                     <a:lnL w="12700" cap="flat" cmpd="sng" algn="ctr">
                       <a:solidFill>
-                        <a:srgbClr val="DCE3F5"/>
+                        <a:srgbClr val="DDE2E9"/>
                       </a:solidFill>
                       <a:prstDash val="solid"/>
                       <a:round/>
@@ -3256,7 +3394,7 @@
                     </a:lnL>
                     <a:lnR w="12700" cap="flat" cmpd="sng" algn="ctr">
                       <a:solidFill>
-                        <a:srgbClr val="DCE3F5"/>
+                        <a:srgbClr val="DDE2E9"/>
                       </a:solidFill>
                       <a:prstDash val="solid"/>
                       <a:round/>
@@ -3265,7 +3403,7 @@
                     </a:lnR>
                     <a:lnT w="12700" cap="flat" cmpd="sng" algn="ctr">
                       <a:solidFill>
-                        <a:srgbClr val="DCE3F5"/>
+                        <a:srgbClr val="DDE2E9"/>
                       </a:solidFill>
                       <a:prstDash val="solid"/>
                       <a:round/>
@@ -3274,7 +3412,7 @@
                     </a:lnT>
                     <a:lnB w="12700" cap="flat" cmpd="sng" algn="ctr">
                       <a:solidFill>
-                        <a:srgbClr val="DCE3F5"/>
+                        <a:srgbClr val="DDE2E9"/>
                       </a:solidFill>
                       <a:prstDash val="solid"/>
                       <a:round/>
@@ -3297,7 +3435,7 @@
                       <a:r>
                         <a:rPr lang="en-US" sz="1100" dirty="0">
                           <a:solidFill>
-                            <a:srgbClr val="16203F"/>
+                            <a:srgbClr val="232A36"/>
                           </a:solidFill>
                           <a:latin typeface="Yu Gothic" pitchFamily="34" charset="0"/>
                           <a:ea typeface="Yu Gothic" pitchFamily="34" charset="-122"/>
@@ -3315,7 +3453,7 @@
                   <a:tcPr marL="73152" marR="73152" marT="73152" marB="73152" anchor="ctr">
                     <a:lnL w="12700" cap="flat" cmpd="sng" algn="ctr">
                       <a:solidFill>
-                        <a:srgbClr val="DCE3F5"/>
+                        <a:srgbClr val="DDE2E9"/>
                       </a:solidFill>
                       <a:prstDash val="solid"/>
                       <a:round/>
@@ -3324,7 +3462,7 @@
                     </a:lnL>
                     <a:lnR w="12700" cap="flat" cmpd="sng" algn="ctr">
                       <a:solidFill>
-                        <a:srgbClr val="DCE3F5"/>
+                        <a:srgbClr val="DDE2E9"/>
                       </a:solidFill>
                       <a:prstDash val="solid"/>
                       <a:round/>
@@ -3333,7 +3471,7 @@
                     </a:lnR>
                     <a:lnT w="12700" cap="flat" cmpd="sng" algn="ctr">
                       <a:solidFill>
-                        <a:srgbClr val="DCE3F5"/>
+                        <a:srgbClr val="DDE2E9"/>
                       </a:solidFill>
                       <a:prstDash val="solid"/>
                       <a:round/>
@@ -3342,7 +3480,7 @@
                     </a:lnT>
                     <a:lnB w="12700" cap="flat" cmpd="sng" algn="ctr">
                       <a:solidFill>
-                        <a:srgbClr val="DCE3F5"/>
+                        <a:srgbClr val="DDE2E9"/>
                       </a:solidFill>
                       <a:prstDash val="solid"/>
                       <a:round/>
@@ -3386,7 +3524,7 @@
             <a:r>
               <a:rPr lang="en-US" sz="1100" dirty="0">
                 <a:solidFill>
-                  <a:srgbClr val="5B6485"/>
+                  <a:srgbClr val="636C7C"/>
                 </a:solidFill>
                 <a:latin typeface="Yu Gothic" pitchFamily="34" charset="0"/>
                 <a:ea typeface="Yu Gothic" pitchFamily="34" charset="-122"/>
@@ -3425,7 +3563,7 @@
             <a:r>
               <a:rPr lang="en-US" sz="1150" b="1" dirty="0">
                 <a:solidFill>
-                  <a:srgbClr val="5B6485"/>
+                  <a:srgbClr val="636C7C"/>
                 </a:solidFill>
                 <a:latin typeface="Yu Gothic" pitchFamily="34" charset="0"/>
                 <a:ea typeface="Yu Gothic" pitchFamily="34" charset="-122"/>
@@ -3467,7 +3605,7 @@
             <a:r>
               <a:rPr lang="en-US" sz="1250" dirty="0">
                 <a:solidFill>
-                  <a:srgbClr val="16203F"/>
+                  <a:srgbClr val="232A36"/>
                 </a:solidFill>
                 <a:latin typeface="Yu Gothic" pitchFamily="34" charset="0"/>
                 <a:ea typeface="Yu Gothic" pitchFamily="34" charset="-122"/>
@@ -3496,7 +3634,7 @@
             </a:avLst>
           </a:prstGeom>
           <a:solidFill>
-            <a:srgbClr val="EEF2FB"/>
+            <a:srgbClr val="EDF0F4"/>
           </a:solidFill>
           <a:ln/>
         </p:spPr>
@@ -3531,7 +3669,7 @@
             <a:r>
               <a:rPr lang="en-US" sz="1000" dirty="0">
                 <a:solidFill>
-                  <a:srgbClr val="1E2761"/>
+                  <a:srgbClr val="434E60"/>
                 </a:solidFill>
                 <a:latin typeface="Courier New" pitchFamily="34" charset="0"/>
                 <a:ea typeface="Courier New" pitchFamily="34" charset="-122"/>
@@ -3551,7 +3689,7 @@
             <a:r>
               <a:rPr lang="en-US" sz="1000" dirty="0">
                 <a:solidFill>
-                  <a:srgbClr val="1E2761"/>
+                  <a:srgbClr val="434E60"/>
                 </a:solidFill>
                 <a:latin typeface="Courier New" pitchFamily="34" charset="0"/>
                 <a:ea typeface="Courier New" pitchFamily="34" charset="-122"/>
@@ -3571,7 +3709,7 @@
             <a:r>
               <a:rPr lang="en-US" sz="1000" dirty="0">
                 <a:solidFill>
-                  <a:srgbClr val="1E2761"/>
+                  <a:srgbClr val="434E60"/>
                 </a:solidFill>
                 <a:latin typeface="Courier New" pitchFamily="34" charset="0"/>
                 <a:ea typeface="Courier New" pitchFamily="34" charset="-122"/>
@@ -3591,7 +3729,7 @@
             <a:r>
               <a:rPr lang="en-US" sz="1000" dirty="0">
                 <a:solidFill>
-                  <a:srgbClr val="1E2761"/>
+                  <a:srgbClr val="434E60"/>
                 </a:solidFill>
                 <a:latin typeface="Courier New" pitchFamily="34" charset="0"/>
                 <a:ea typeface="Courier New" pitchFamily="34" charset="-122"/>
@@ -3620,7 +3758,7 @@
             </a:avLst>
           </a:prstGeom>
           <a:solidFill>
-            <a:srgbClr val="F4F7FD"/>
+            <a:srgbClr val="F2F4F7"/>
           </a:solidFill>
           <a:ln/>
         </p:spPr>
@@ -3694,7 +3832,7 @@
             <a:r>
               <a:rPr lang="en-US" sz="1150" dirty="0">
                 <a:solidFill>
-                  <a:srgbClr val="5B6485"/>
+                  <a:srgbClr val="636C7C"/>
                 </a:solidFill>
                 <a:latin typeface="Yu Gothic" pitchFamily="34" charset="0"/>
                 <a:ea typeface="Yu Gothic" pitchFamily="34" charset="-122"/>
@@ -3714,7 +3852,7 @@
             <a:r>
               <a:rPr lang="en-US" sz="2400" b="1" dirty="0">
                 <a:solidFill>
-                  <a:srgbClr val="5B6485"/>
+                  <a:srgbClr val="636C7C"/>
                 </a:solidFill>
                 <a:latin typeface="Yu Gothic" pitchFamily="34" charset="0"/>
                 <a:ea typeface="Yu Gothic" pitchFamily="34" charset="-122"/>
@@ -3734,7 +3872,7 @@
             <a:r>
               <a:rPr lang="en-US" sz="1150" dirty="0">
                 <a:solidFill>
-                  <a:srgbClr val="16203F"/>
+                  <a:srgbClr val="232A36"/>
                 </a:solidFill>
                 <a:latin typeface="Yu Gothic" pitchFamily="34" charset="0"/>
                 <a:ea typeface="Yu Gothic" pitchFamily="34" charset="-122"/>
@@ -3754,7 +3892,7 @@
             <a:r>
               <a:rPr lang="en-US" sz="2400" b="1" dirty="0">
                 <a:solidFill>
-                  <a:srgbClr val="1E2761"/>
+                  <a:srgbClr val="434E60"/>
                 </a:solidFill>
                 <a:latin typeface="Yu Gothic" pitchFamily="34" charset="0"/>
                 <a:ea typeface="Yu Gothic" pitchFamily="34" charset="-122"/>
@@ -3793,7 +3931,7 @@
             <a:r>
               <a:rPr lang="en-US" sz="1150" dirty="0">
                 <a:solidFill>
-                  <a:srgbClr val="5B6485"/>
+                  <a:srgbClr val="636C7C"/>
                 </a:solidFill>
                 <a:latin typeface="Yu Gothic" pitchFamily="34" charset="0"/>
                 <a:ea typeface="Yu Gothic" pitchFamily="34" charset="-122"/>
@@ -3903,7 +4041,7 @@
             <a:r>
               <a:rPr lang="en-US" sz="2800" b="1" dirty="0">
                 <a:solidFill>
-                  <a:srgbClr val="16203F"/>
+                  <a:srgbClr val="232A36"/>
                 </a:solidFill>
                 <a:latin typeface="Yu Gothic" pitchFamily="34" charset="0"/>
                 <a:ea typeface="Yu Gothic" pitchFamily="34" charset="-122"/>
@@ -3942,7 +4080,7 @@
             <a:r>
               <a:rPr lang="en-US" sz="1150" b="1" dirty="0">
                 <a:solidFill>
-                  <a:srgbClr val="5B6485"/>
+                  <a:srgbClr val="636C7C"/>
                 </a:solidFill>
                 <a:latin typeface="Yu Gothic" pitchFamily="34" charset="0"/>
                 <a:ea typeface="Yu Gothic" pitchFamily="34" charset="-122"/>
@@ -3984,7 +4122,7 @@
             <a:r>
               <a:rPr lang="en-US" sz="1250" dirty="0">
                 <a:solidFill>
-                  <a:srgbClr val="16203F"/>
+                  <a:srgbClr val="232A36"/>
                 </a:solidFill>
                 <a:latin typeface="Yu Gothic" pitchFamily="34" charset="0"/>
                 <a:ea typeface="Yu Gothic" pitchFamily="34" charset="-122"/>
@@ -4023,7 +4161,7 @@
             <a:r>
               <a:rPr lang="en-US" sz="1150" b="1" dirty="0">
                 <a:solidFill>
-                  <a:srgbClr val="5B6485"/>
+                  <a:srgbClr val="636C7C"/>
                 </a:solidFill>
                 <a:latin typeface="Yu Gothic" pitchFamily="34" charset="0"/>
                 <a:ea typeface="Yu Gothic" pitchFamily="34" charset="-122"/>
@@ -4052,7 +4190,7 @@
             </a:avLst>
           </a:prstGeom>
           <a:solidFill>
-            <a:srgbClr val="FAFBFE"/>
+            <a:srgbClr val="FAFBFC"/>
           </a:solidFill>
           <a:ln/>
         </p:spPr>
@@ -4084,7 +4222,7 @@
             <a:r>
               <a:rPr lang="en-US" sz="1200" b="1" dirty="0">
                 <a:solidFill>
-                  <a:srgbClr val="5B6485"/>
+                  <a:srgbClr val="636C7C"/>
                 </a:solidFill>
                 <a:latin typeface="Yu Gothic" pitchFamily="34" charset="0"/>
                 <a:ea typeface="Yu Gothic" pitchFamily="34" charset="-122"/>
@@ -4126,7 +4264,7 @@
             <a:r>
               <a:rPr lang="en-US" sz="1100" dirty="0">
                 <a:solidFill>
-                  <a:srgbClr val="5B6485"/>
+                  <a:srgbClr val="636C7C"/>
                 </a:solidFill>
                 <a:latin typeface="Yu Gothic" pitchFamily="34" charset="0"/>
                 <a:ea typeface="Yu Gothic" pitchFamily="34" charset="-122"/>
@@ -4168,7 +4306,7 @@
             <a:r>
               <a:rPr lang="en-US" sz="1050" dirty="0">
                 <a:solidFill>
-                  <a:srgbClr val="5B6485"/>
+                  <a:srgbClr val="636C7C"/>
                 </a:solidFill>
                 <a:latin typeface="Yu Gothic" pitchFamily="34" charset="0"/>
                 <a:ea typeface="Yu Gothic" pitchFamily="34" charset="-122"/>
@@ -4197,7 +4335,7 @@
             </a:avLst>
           </a:prstGeom>
           <a:solidFill>
-            <a:srgbClr val="FAFBFE"/>
+            <a:srgbClr val="FAFBFC"/>
           </a:solidFill>
           <a:ln/>
         </p:spPr>
@@ -4229,7 +4367,7 @@
             <a:r>
               <a:rPr lang="en-US" sz="1200" b="1" dirty="0">
                 <a:solidFill>
-                  <a:srgbClr val="5B6485"/>
+                  <a:srgbClr val="636C7C"/>
                 </a:solidFill>
                 <a:latin typeface="Yu Gothic" pitchFamily="34" charset="0"/>
                 <a:ea typeface="Yu Gothic" pitchFamily="34" charset="-122"/>
@@ -4271,7 +4409,7 @@
             <a:r>
               <a:rPr lang="en-US" sz="1100" dirty="0">
                 <a:solidFill>
-                  <a:srgbClr val="5B6485"/>
+                  <a:srgbClr val="636C7C"/>
                 </a:solidFill>
                 <a:latin typeface="Yu Gothic" pitchFamily="34" charset="0"/>
                 <a:ea typeface="Yu Gothic" pitchFamily="34" charset="-122"/>
@@ -4313,7 +4451,7 @@
             <a:r>
               <a:rPr lang="en-US" sz="1050" dirty="0">
                 <a:solidFill>
-                  <a:srgbClr val="5B6485"/>
+                  <a:srgbClr val="636C7C"/>
                 </a:solidFill>
                 <a:latin typeface="Yu Gothic" pitchFamily="34" charset="0"/>
                 <a:ea typeface="Yu Gothic" pitchFamily="34" charset="-122"/>
@@ -4342,7 +4480,7 @@
             </a:avLst>
           </a:prstGeom>
           <a:solidFill>
-            <a:srgbClr val="F4F7FD"/>
+            <a:srgbClr val="F2F4F7"/>
           </a:solidFill>
           <a:ln/>
         </p:spPr>
@@ -4416,7 +4554,7 @@
             <a:r>
               <a:rPr lang="en-US" sz="1100" b="1" dirty="0">
                 <a:solidFill>
-                  <a:srgbClr val="1E2761"/>
+                  <a:srgbClr val="434E60"/>
                 </a:solidFill>
                 <a:latin typeface="Yu Gothic" pitchFamily="34" charset="0"/>
                 <a:ea typeface="Yu Gothic" pitchFamily="34" charset="-122"/>
@@ -4436,7 +4574,7 @@
             <a:r>
               <a:rPr lang="en-US" sz="1100" b="1" dirty="0">
                 <a:solidFill>
-                  <a:srgbClr val="1E2761"/>
+                  <a:srgbClr val="434E60"/>
                 </a:solidFill>
                 <a:latin typeface="Yu Gothic" pitchFamily="34" charset="0"/>
                 <a:ea typeface="Yu Gothic" pitchFamily="34" charset="-122"/>
@@ -4478,7 +4616,7 @@
             <a:r>
               <a:rPr lang="en-US" sz="1050" dirty="0">
                 <a:solidFill>
-                  <a:srgbClr val="1E2761"/>
+                  <a:srgbClr val="434E60"/>
                 </a:solidFill>
                 <a:latin typeface="Yu Gothic" pitchFamily="34" charset="0"/>
                 <a:ea typeface="Yu Gothic" pitchFamily="34" charset="-122"/>
@@ -4498,7 +4636,7 @@
             <a:r>
               <a:rPr lang="en-US" sz="1050" dirty="0">
                 <a:solidFill>
-                  <a:srgbClr val="1E2761"/>
+                  <a:srgbClr val="434E60"/>
                 </a:solidFill>
                 <a:latin typeface="Yu Gothic" pitchFamily="34" charset="0"/>
                 <a:ea typeface="Yu Gothic" pitchFamily="34" charset="-122"/>
@@ -4537,7 +4675,7 @@
             <a:r>
               <a:rPr lang="en-US" sz="1150" b="1" dirty="0">
                 <a:solidFill>
-                  <a:srgbClr val="5B6485"/>
+                  <a:srgbClr val="636C7C"/>
                 </a:solidFill>
                 <a:latin typeface="Yu Gothic" pitchFamily="34" charset="0"/>
                 <a:ea typeface="Yu Gothic" pitchFamily="34" charset="-122"/>
@@ -4579,7 +4717,7 @@
             <a:r>
               <a:rPr lang="en-US" sz="1100" dirty="0">
                 <a:solidFill>
-                  <a:srgbClr val="16203F"/>
+                  <a:srgbClr val="232A36"/>
                 </a:solidFill>
                 <a:latin typeface="Yu Gothic" pitchFamily="34" charset="0"/>
                 <a:ea typeface="Yu Gothic" pitchFamily="34" charset="-122"/>
@@ -4618,7 +4756,7 @@
             <a:r>
               <a:rPr lang="en-US" sz="1150" b="1" dirty="0">
                 <a:solidFill>
-                  <a:srgbClr val="5B6485"/>
+                  <a:srgbClr val="636C7C"/>
                 </a:solidFill>
                 <a:latin typeface="Yu Gothic" pitchFamily="34" charset="0"/>
                 <a:ea typeface="Yu Gothic" pitchFamily="34" charset="-122"/>
@@ -4681,7 +4819,7 @@
             <a:r>
               <a:rPr lang="en-US" sz="1050" dirty="0">
                 <a:solidFill>
-                  <a:srgbClr val="5B6485"/>
+                  <a:srgbClr val="636C7C"/>
                 </a:solidFill>
                 <a:latin typeface="Yu Gothic" pitchFamily="34" charset="0"/>
                 <a:ea typeface="Yu Gothic" pitchFamily="34" charset="-122"/>
@@ -4710,7 +4848,7 @@
             </a:avLst>
           </a:prstGeom>
           <a:solidFill>
-            <a:srgbClr val="F4F7FD"/>
+            <a:srgbClr val="F2F4F7"/>
           </a:solidFill>
           <a:ln/>
         </p:spPr>
@@ -4742,7 +4880,7 @@
             <a:r>
               <a:rPr lang="en-US" sz="1150" b="1" dirty="0">
                 <a:solidFill>
-                  <a:srgbClr val="5B6485"/>
+                  <a:srgbClr val="636C7C"/>
                 </a:solidFill>
                 <a:latin typeface="Yu Gothic" pitchFamily="34" charset="0"/>
                 <a:ea typeface="Yu Gothic" pitchFamily="34" charset="-122"/>
@@ -4784,7 +4922,7 @@
             <a:r>
               <a:rPr lang="en-US" sz="1100" dirty="0">
                 <a:solidFill>
-                  <a:srgbClr val="16203F"/>
+                  <a:srgbClr val="232A36"/>
                 </a:solidFill>
                 <a:latin typeface="Yu Gothic" pitchFamily="34" charset="0"/>
                 <a:ea typeface="Yu Gothic" pitchFamily="34" charset="-122"/>
@@ -4894,7 +5032,7 @@
             <a:r>
               <a:rPr lang="en-US" sz="2800" b="1" dirty="0">
                 <a:solidFill>
-                  <a:srgbClr val="16203F"/>
+                  <a:srgbClr val="232A36"/>
                 </a:solidFill>
                 <a:latin typeface="Yu Gothic" pitchFamily="34" charset="0"/>
                 <a:ea typeface="Yu Gothic" pitchFamily="34" charset="-122"/>
@@ -4923,7 +5061,7 @@
             </a:avLst>
           </a:prstGeom>
           <a:solidFill>
-            <a:srgbClr val="F4F7FD"/>
+            <a:srgbClr val="F2F4F7"/>
           </a:solidFill>
           <a:ln/>
         </p:spPr>
@@ -4955,7 +5093,7 @@
             <a:r>
               <a:rPr lang="en-US" sz="1400" b="1" dirty="0">
                 <a:solidFill>
-                  <a:srgbClr val="1E2761"/>
+                  <a:srgbClr val="434E60"/>
                 </a:solidFill>
                 <a:latin typeface="Yu Gothic" pitchFamily="34" charset="0"/>
                 <a:ea typeface="Yu Gothic" pitchFamily="34" charset="-122"/>
@@ -5039,7 +5177,7 @@
             <a:r>
               <a:rPr lang="en-US" sz="1050" dirty="0">
                 <a:solidFill>
-                  <a:srgbClr val="16203F"/>
+                  <a:srgbClr val="232A36"/>
                 </a:solidFill>
                 <a:latin typeface="Yu Gothic" pitchFamily="34" charset="0"/>
                 <a:ea typeface="Yu Gothic" pitchFamily="34" charset="-122"/>
@@ -5068,7 +5206,7 @@
             </a:avLst>
           </a:prstGeom>
           <a:solidFill>
-            <a:srgbClr val="F4F7FD"/>
+            <a:srgbClr val="F2F4F7"/>
           </a:solidFill>
           <a:ln/>
         </p:spPr>
@@ -5100,7 +5238,7 @@
             <a:r>
               <a:rPr lang="en-US" sz="1400" b="1" dirty="0">
                 <a:solidFill>
-                  <a:srgbClr val="1E2761"/>
+                  <a:srgbClr val="434E60"/>
                 </a:solidFill>
                 <a:latin typeface="Yu Gothic" pitchFamily="34" charset="0"/>
                 <a:ea typeface="Yu Gothic" pitchFamily="34" charset="-122"/>
@@ -5184,7 +5322,7 @@
             <a:r>
               <a:rPr lang="en-US" sz="1050" dirty="0">
                 <a:solidFill>
-                  <a:srgbClr val="16203F"/>
+                  <a:srgbClr val="232A36"/>
                 </a:solidFill>
                 <a:latin typeface="Yu Gothic" pitchFamily="34" charset="0"/>
                 <a:ea typeface="Yu Gothic" pitchFamily="34" charset="-122"/>
@@ -5213,7 +5351,7 @@
             </a:avLst>
           </a:prstGeom>
           <a:solidFill>
-            <a:srgbClr val="F4F7FD"/>
+            <a:srgbClr val="F2F4F7"/>
           </a:solidFill>
           <a:ln/>
         </p:spPr>
@@ -5245,7 +5383,7 @@
             <a:r>
               <a:rPr lang="en-US" sz="1400" b="1" dirty="0">
                 <a:solidFill>
-                  <a:srgbClr val="1E2761"/>
+                  <a:srgbClr val="434E60"/>
                 </a:solidFill>
                 <a:latin typeface="Yu Gothic" pitchFamily="34" charset="0"/>
                 <a:ea typeface="Yu Gothic" pitchFamily="34" charset="-122"/>
@@ -5329,7 +5467,7 @@
             <a:r>
               <a:rPr lang="en-US" sz="1050" dirty="0">
                 <a:solidFill>
-                  <a:srgbClr val="16203F"/>
+                  <a:srgbClr val="232A36"/>
                 </a:solidFill>
                 <a:latin typeface="Yu Gothic" pitchFamily="34" charset="0"/>
                 <a:ea typeface="Yu Gothic" pitchFamily="34" charset="-122"/>
@@ -5358,7 +5496,7 @@
             </a:avLst>
           </a:prstGeom>
           <a:solidFill>
-            <a:srgbClr val="F4F7FD"/>
+            <a:srgbClr val="F2F4F7"/>
           </a:solidFill>
           <a:ln/>
         </p:spPr>
@@ -5432,7 +5570,7 @@
             <a:r>
               <a:rPr lang="en-US" sz="1150" dirty="0">
                 <a:solidFill>
-                  <a:srgbClr val="16203F"/>
+                  <a:srgbClr val="232A36"/>
                 </a:solidFill>
                 <a:latin typeface="Yu Gothic" pitchFamily="34" charset="0"/>
                 <a:ea typeface="Yu Gothic" pitchFamily="34" charset="-122"/>
@@ -5461,7 +5599,7 @@
             </a:avLst>
           </a:prstGeom>
           <a:solidFill>
-            <a:srgbClr val="F4F7FD"/>
+            <a:srgbClr val="F2F4F7"/>
           </a:solidFill>
           <a:ln/>
         </p:spPr>
@@ -5493,7 +5631,7 @@
             <a:r>
               <a:rPr lang="en-US" sz="1150" b="1" dirty="0">
                 <a:solidFill>
-                  <a:srgbClr val="5B6485"/>
+                  <a:srgbClr val="636C7C"/>
                 </a:solidFill>
                 <a:latin typeface="Yu Gothic" pitchFamily="34" charset="0"/>
                 <a:ea typeface="Yu Gothic" pitchFamily="34" charset="-122"/>
@@ -5535,7 +5673,7 @@
             <a:r>
               <a:rPr lang="en-US" sz="1150" dirty="0">
                 <a:solidFill>
-                  <a:srgbClr val="16203F"/>
+                  <a:srgbClr val="232A36"/>
                 </a:solidFill>
                 <a:latin typeface="Yu Gothic" pitchFamily="34" charset="0"/>
                 <a:ea typeface="Yu Gothic" pitchFamily="34" charset="-122"/>
@@ -5574,7 +5712,7 @@
             <a:r>
               <a:rPr lang="en-US" sz="1100" dirty="0">
                 <a:solidFill>
-                  <a:srgbClr val="5B6485"/>
+                  <a:srgbClr val="636C7C"/>
                 </a:solidFill>
                 <a:latin typeface="Yu Gothic" pitchFamily="34" charset="0"/>
                 <a:ea typeface="Yu Gothic" pitchFamily="34" charset="-122"/>
@@ -5684,7 +5822,7 @@
             <a:r>
               <a:rPr lang="en-US" sz="2800" b="1" dirty="0">
                 <a:solidFill>
-                  <a:srgbClr val="16203F"/>
+                  <a:srgbClr val="232A36"/>
                 </a:solidFill>
                 <a:latin typeface="Yu Gothic" pitchFamily="34" charset="0"/>
                 <a:ea typeface="Yu Gothic" pitchFamily="34" charset="-122"/>
@@ -5713,7 +5851,7 @@
             </a:avLst>
           </a:prstGeom>
           <a:solidFill>
-            <a:srgbClr val="F4F7FD"/>
+            <a:srgbClr val="F2F4F7"/>
           </a:solidFill>
           <a:ln/>
         </p:spPr>
@@ -5745,7 +5883,7 @@
             <a:r>
               <a:rPr lang="en-US" sz="1200" b="1" dirty="0">
                 <a:solidFill>
-                  <a:srgbClr val="16203F"/>
+                  <a:srgbClr val="232A36"/>
                 </a:solidFill>
                 <a:latin typeface="Yu Gothic" pitchFamily="34" charset="0"/>
                 <a:ea typeface="Yu Gothic" pitchFamily="34" charset="-122"/>
@@ -5787,7 +5925,7 @@
             <a:r>
               <a:rPr lang="en-US" sz="1000" dirty="0">
                 <a:solidFill>
-                  <a:srgbClr val="5B6485"/>
+                  <a:srgbClr val="636C7C"/>
                 </a:solidFill>
                 <a:latin typeface="Yu Gothic" pitchFamily="34" charset="0"/>
                 <a:ea typeface="Yu Gothic" pitchFamily="34" charset="-122"/>
@@ -5807,7 +5945,7 @@
             <a:r>
               <a:rPr lang="en-US" sz="1000" dirty="0">
                 <a:solidFill>
-                  <a:srgbClr val="5B6485"/>
+                  <a:srgbClr val="636C7C"/>
                 </a:solidFill>
                 <a:latin typeface="Yu Gothic" pitchFamily="34" charset="0"/>
                 <a:ea typeface="Yu Gothic" pitchFamily="34" charset="-122"/>
@@ -5834,7 +5972,7 @@
             <a:avLst/>
           </a:prstGeom>
           <a:solidFill>
-            <a:srgbClr val="8FB3E8"/>
+            <a:srgbClr val="AEBACB"/>
           </a:solidFill>
           <a:ln/>
         </p:spPr>
@@ -5856,7 +5994,7 @@
             </a:avLst>
           </a:prstGeom>
           <a:solidFill>
-            <a:srgbClr val="F4F7FD"/>
+            <a:srgbClr val="F2F4F7"/>
           </a:solidFill>
           <a:ln/>
         </p:spPr>
@@ -5888,7 +6026,7 @@
             <a:r>
               <a:rPr lang="en-US" sz="1200" b="1" dirty="0">
                 <a:solidFill>
-                  <a:srgbClr val="16203F"/>
+                  <a:srgbClr val="232A36"/>
                 </a:solidFill>
                 <a:latin typeface="Yu Gothic" pitchFamily="34" charset="0"/>
                 <a:ea typeface="Yu Gothic" pitchFamily="34" charset="-122"/>
@@ -5930,7 +6068,7 @@
             <a:r>
               <a:rPr lang="en-US" sz="1000" dirty="0">
                 <a:solidFill>
-                  <a:srgbClr val="5B6485"/>
+                  <a:srgbClr val="636C7C"/>
                 </a:solidFill>
                 <a:latin typeface="Yu Gothic" pitchFamily="34" charset="0"/>
                 <a:ea typeface="Yu Gothic" pitchFamily="34" charset="-122"/>
@@ -5950,7 +6088,7 @@
             <a:r>
               <a:rPr lang="en-US" sz="1000" dirty="0">
                 <a:solidFill>
-                  <a:srgbClr val="5B6485"/>
+                  <a:srgbClr val="636C7C"/>
                 </a:solidFill>
                 <a:latin typeface="Yu Gothic" pitchFamily="34" charset="0"/>
                 <a:ea typeface="Yu Gothic" pitchFamily="34" charset="-122"/>
@@ -5977,7 +6115,7 @@
             <a:avLst/>
           </a:prstGeom>
           <a:solidFill>
-            <a:srgbClr val="8FB3E8"/>
+            <a:srgbClr val="AEBACB"/>
           </a:solidFill>
           <a:ln/>
         </p:spPr>
@@ -5999,7 +6137,7 @@
             </a:avLst>
           </a:prstGeom>
           <a:solidFill>
-            <a:srgbClr val="F4F7FD"/>
+            <a:srgbClr val="F2F4F7"/>
           </a:solidFill>
           <a:ln/>
         </p:spPr>
@@ -6031,7 +6169,7 @@
             <a:r>
               <a:rPr lang="en-US" sz="1200" b="1" dirty="0">
                 <a:solidFill>
-                  <a:srgbClr val="16203F"/>
+                  <a:srgbClr val="232A36"/>
                 </a:solidFill>
                 <a:latin typeface="Yu Gothic" pitchFamily="34" charset="0"/>
                 <a:ea typeface="Yu Gothic" pitchFamily="34" charset="-122"/>
@@ -6073,7 +6211,7 @@
             <a:r>
               <a:rPr lang="en-US" sz="1000" dirty="0">
                 <a:solidFill>
-                  <a:srgbClr val="5B6485"/>
+                  <a:srgbClr val="636C7C"/>
                 </a:solidFill>
                 <a:latin typeface="Yu Gothic" pitchFamily="34" charset="0"/>
                 <a:ea typeface="Yu Gothic" pitchFamily="34" charset="-122"/>
@@ -6093,7 +6231,7 @@
             <a:r>
               <a:rPr lang="en-US" sz="1000" dirty="0">
                 <a:solidFill>
-                  <a:srgbClr val="5B6485"/>
+                  <a:srgbClr val="636C7C"/>
                 </a:solidFill>
                 <a:latin typeface="Yu Gothic" pitchFamily="34" charset="0"/>
                 <a:ea typeface="Yu Gothic" pitchFamily="34" charset="-122"/>
@@ -6120,7 +6258,7 @@
             <a:avLst/>
           </a:prstGeom>
           <a:solidFill>
-            <a:srgbClr val="8FB3E8"/>
+            <a:srgbClr val="AEBACB"/>
           </a:solidFill>
           <a:ln/>
         </p:spPr>
@@ -6142,7 +6280,7 @@
             </a:avLst>
           </a:prstGeom>
           <a:solidFill>
-            <a:srgbClr val="F4F7FD"/>
+            <a:srgbClr val="F2F4F7"/>
           </a:solidFill>
           <a:ln/>
         </p:spPr>
@@ -6174,7 +6312,7 @@
             <a:r>
               <a:rPr lang="en-US" sz="1200" b="1" dirty="0">
                 <a:solidFill>
-                  <a:srgbClr val="16203F"/>
+                  <a:srgbClr val="232A36"/>
                 </a:solidFill>
                 <a:latin typeface="Yu Gothic" pitchFamily="34" charset="0"/>
                 <a:ea typeface="Yu Gothic" pitchFamily="34" charset="-122"/>
@@ -6216,7 +6354,7 @@
             <a:r>
               <a:rPr lang="en-US" sz="1000" dirty="0">
                 <a:solidFill>
-                  <a:srgbClr val="5B6485"/>
+                  <a:srgbClr val="636C7C"/>
                 </a:solidFill>
                 <a:latin typeface="Yu Gothic" pitchFamily="34" charset="0"/>
                 <a:ea typeface="Yu Gothic" pitchFamily="34" charset="-122"/>
@@ -6236,7 +6374,7 @@
             <a:r>
               <a:rPr lang="en-US" sz="1000" dirty="0">
                 <a:solidFill>
-                  <a:srgbClr val="5B6485"/>
+                  <a:srgbClr val="636C7C"/>
                 </a:solidFill>
                 <a:latin typeface="Yu Gothic" pitchFamily="34" charset="0"/>
                 <a:ea typeface="Yu Gothic" pitchFamily="34" charset="-122"/>
@@ -6263,7 +6401,7 @@
             <a:avLst/>
           </a:prstGeom>
           <a:solidFill>
-            <a:srgbClr val="8FB3E8"/>
+            <a:srgbClr val="AEBACB"/>
           </a:solidFill>
           <a:ln/>
         </p:spPr>
@@ -6285,7 +6423,7 @@
             </a:avLst>
           </a:prstGeom>
           <a:solidFill>
-            <a:srgbClr val="F4F7FD"/>
+            <a:srgbClr val="F2F4F7"/>
           </a:solidFill>
           <a:ln/>
         </p:spPr>
@@ -6317,7 +6455,7 @@
             <a:r>
               <a:rPr lang="en-US" sz="1200" b="1" dirty="0">
                 <a:solidFill>
-                  <a:srgbClr val="16203F"/>
+                  <a:srgbClr val="232A36"/>
                 </a:solidFill>
                 <a:latin typeface="Yu Gothic" pitchFamily="34" charset="0"/>
                 <a:ea typeface="Yu Gothic" pitchFamily="34" charset="-122"/>
@@ -6359,7 +6497,7 @@
             <a:r>
               <a:rPr lang="en-US" sz="1000" dirty="0">
                 <a:solidFill>
-                  <a:srgbClr val="5B6485"/>
+                  <a:srgbClr val="636C7C"/>
                 </a:solidFill>
                 <a:latin typeface="Yu Gothic" pitchFamily="34" charset="0"/>
                 <a:ea typeface="Yu Gothic" pitchFamily="34" charset="-122"/>
@@ -6379,7 +6517,7 @@
             <a:r>
               <a:rPr lang="en-US" sz="1000" dirty="0">
                 <a:solidFill>
-                  <a:srgbClr val="5B6485"/>
+                  <a:srgbClr val="636C7C"/>
                 </a:solidFill>
                 <a:latin typeface="Yu Gothic" pitchFamily="34" charset="0"/>
                 <a:ea typeface="Yu Gothic" pitchFamily="34" charset="-122"/>
@@ -6406,7 +6544,7 @@
             <a:avLst/>
           </a:prstGeom>
           <a:solidFill>
-            <a:srgbClr val="8FB3E8"/>
+            <a:srgbClr val="AEBACB"/>
           </a:solidFill>
           <a:ln/>
         </p:spPr>
@@ -6428,7 +6566,7 @@
             </a:avLst>
           </a:prstGeom>
           <a:solidFill>
-            <a:srgbClr val="CADCFC"/>
+            <a:srgbClr val="DCE2EA"/>
           </a:solidFill>
           <a:ln/>
         </p:spPr>
@@ -6460,7 +6598,7 @@
             <a:r>
               <a:rPr lang="en-US" sz="1200" b="1" dirty="0">
                 <a:solidFill>
-                  <a:srgbClr val="1E2761"/>
+                  <a:srgbClr val="434E60"/>
                 </a:solidFill>
                 <a:latin typeface="Yu Gothic" pitchFamily="34" charset="0"/>
                 <a:ea typeface="Yu Gothic" pitchFamily="34" charset="-122"/>
@@ -6502,7 +6640,7 @@
             <a:r>
               <a:rPr lang="en-US" sz="1000" dirty="0">
                 <a:solidFill>
-                  <a:srgbClr val="1E2761"/>
+                  <a:srgbClr val="434E60"/>
                 </a:solidFill>
                 <a:latin typeface="Yu Gothic" pitchFamily="34" charset="0"/>
                 <a:ea typeface="Yu Gothic" pitchFamily="34" charset="-122"/>
@@ -6522,7 +6660,7 @@
             <a:r>
               <a:rPr lang="en-US" sz="1000" dirty="0">
                 <a:solidFill>
-                  <a:srgbClr val="1E2761"/>
+                  <a:srgbClr val="434E60"/>
                 </a:solidFill>
                 <a:latin typeface="Yu Gothic" pitchFamily="34" charset="0"/>
                 <a:ea typeface="Yu Gothic" pitchFamily="34" charset="-122"/>
@@ -6551,7 +6689,7 @@
             </a:avLst>
           </a:prstGeom>
           <a:solidFill>
-            <a:srgbClr val="F4F7FD"/>
+            <a:srgbClr val="F2F4F7"/>
           </a:solidFill>
           <a:ln/>
         </p:spPr>
@@ -6583,7 +6721,7 @@
             <a:r>
               <a:rPr lang="en-US" sz="1150" b="1" dirty="0">
                 <a:solidFill>
-                  <a:srgbClr val="5B6485"/>
+                  <a:srgbClr val="636C7C"/>
                 </a:solidFill>
                 <a:latin typeface="Yu Gothic" pitchFamily="34" charset="0"/>
                 <a:ea typeface="Yu Gothic" pitchFamily="34" charset="-122"/>
@@ -6625,7 +6763,7 @@
             <a:r>
               <a:rPr lang="en-US" sz="1100" dirty="0">
                 <a:solidFill>
-                  <a:srgbClr val="16203F"/>
+                  <a:srgbClr val="232A36"/>
                 </a:solidFill>
                 <a:latin typeface="Yu Gothic" pitchFamily="34" charset="0"/>
                 <a:ea typeface="Yu Gothic" pitchFamily="34" charset="-122"/>
@@ -6645,7 +6783,7 @@
             <a:r>
               <a:rPr lang="en-US" sz="1100" dirty="0">
                 <a:solidFill>
-                  <a:srgbClr val="16203F"/>
+                  <a:srgbClr val="232A36"/>
                 </a:solidFill>
                 <a:latin typeface="Yu Gothic" pitchFamily="34" charset="0"/>
                 <a:ea typeface="Yu Gothic" pitchFamily="34" charset="-122"/>
@@ -6665,7 +6803,7 @@
             <a:r>
               <a:rPr lang="en-US" sz="1100" dirty="0">
                 <a:solidFill>
-                  <a:srgbClr val="16203F"/>
+                  <a:srgbClr val="232A36"/>
                 </a:solidFill>
                 <a:latin typeface="Yu Gothic" pitchFamily="34" charset="0"/>
                 <a:ea typeface="Yu Gothic" pitchFamily="34" charset="-122"/>
@@ -6694,7 +6832,7 @@
             </a:avLst>
           </a:prstGeom>
           <a:solidFill>
-            <a:srgbClr val="F4F7FD"/>
+            <a:srgbClr val="F2F4F7"/>
           </a:solidFill>
           <a:ln/>
         </p:spPr>
@@ -6726,7 +6864,7 @@
             <a:r>
               <a:rPr lang="en-US" sz="1150" b="1" dirty="0">
                 <a:solidFill>
-                  <a:srgbClr val="5B6485"/>
+                  <a:srgbClr val="636C7C"/>
                 </a:solidFill>
                 <a:latin typeface="Yu Gothic" pitchFamily="34" charset="0"/>
                 <a:ea typeface="Yu Gothic" pitchFamily="34" charset="-122"/>
@@ -6768,7 +6906,7 @@
             <a:r>
               <a:rPr lang="en-US" sz="1100" dirty="0">
                 <a:solidFill>
-                  <a:srgbClr val="16203F"/>
+                  <a:srgbClr val="232A36"/>
                 </a:solidFill>
                 <a:latin typeface="Yu Gothic" pitchFamily="34" charset="0"/>
                 <a:ea typeface="Yu Gothic" pitchFamily="34" charset="-122"/>
@@ -6849,7 +6987,7 @@
             <a:r>
               <a:rPr lang="en-US" sz="1150" dirty="0">
                 <a:solidFill>
-                  <a:srgbClr val="16203F"/>
+                  <a:srgbClr val="232A36"/>
                 </a:solidFill>
                 <a:latin typeface="Yu Gothic" pitchFamily="34" charset="0"/>
                 <a:ea typeface="Yu Gothic" pitchFamily="34" charset="-122"/>
@@ -6959,7 +7097,7 @@
             <a:r>
               <a:rPr lang="en-US" sz="2800" b="1" dirty="0">
                 <a:solidFill>
-                  <a:srgbClr val="16203F"/>
+                  <a:srgbClr val="232A36"/>
                 </a:solidFill>
                 <a:latin typeface="Yu Gothic" pitchFamily="34" charset="0"/>
                 <a:ea typeface="Yu Gothic" pitchFamily="34" charset="-122"/>
@@ -6988,7 +7126,7 @@
             </a:avLst>
           </a:prstGeom>
           <a:solidFill>
-            <a:srgbClr val="1E2761"/>
+            <a:srgbClr val="434E60"/>
           </a:solidFill>
           <a:ln/>
         </p:spPr>
@@ -7062,7 +7200,7 @@
             <a:r>
               <a:rPr lang="en-US" sz="1000" dirty="0">
                 <a:solidFill>
-                  <a:srgbClr val="CADCFC"/>
+                  <a:srgbClr val="DCE2EA"/>
                 </a:solidFill>
                 <a:latin typeface="Yu Gothic" pitchFamily="34" charset="0"/>
                 <a:ea typeface="Yu Gothic" pitchFamily="34" charset="-122"/>
@@ -7082,7 +7220,7 @@
             <a:r>
               <a:rPr lang="en-US" sz="1000" dirty="0">
                 <a:solidFill>
-                  <a:srgbClr val="CADCFC"/>
+                  <a:srgbClr val="DCE2EA"/>
                 </a:solidFill>
                 <a:latin typeface="Yu Gothic" pitchFamily="34" charset="0"/>
                 <a:ea typeface="Yu Gothic" pitchFamily="34" charset="-122"/>
@@ -7102,7 +7240,7 @@
             <a:r>
               <a:rPr lang="en-US" sz="1000" dirty="0">
                 <a:solidFill>
-                  <a:srgbClr val="CADCFC"/>
+                  <a:srgbClr val="DCE2EA"/>
                 </a:solidFill>
                 <a:latin typeface="Yu Gothic" pitchFamily="34" charset="0"/>
                 <a:ea typeface="Yu Gothic" pitchFamily="34" charset="-122"/>
@@ -7131,7 +7269,7 @@
             </a:avLst>
           </a:prstGeom>
           <a:solidFill>
-            <a:srgbClr val="1E2761"/>
+            <a:srgbClr val="434E60"/>
           </a:solidFill>
           <a:ln/>
         </p:spPr>
@@ -7205,7 +7343,7 @@
             <a:r>
               <a:rPr lang="en-US" sz="1000" dirty="0">
                 <a:solidFill>
-                  <a:srgbClr val="CADCFC"/>
+                  <a:srgbClr val="DCE2EA"/>
                 </a:solidFill>
                 <a:latin typeface="Yu Gothic" pitchFamily="34" charset="0"/>
                 <a:ea typeface="Yu Gothic" pitchFamily="34" charset="-122"/>
@@ -7225,7 +7363,7 @@
             <a:r>
               <a:rPr lang="en-US" sz="1000" dirty="0">
                 <a:solidFill>
-                  <a:srgbClr val="CADCFC"/>
+                  <a:srgbClr val="DCE2EA"/>
                 </a:solidFill>
                 <a:latin typeface="Yu Gothic" pitchFamily="34" charset="0"/>
                 <a:ea typeface="Yu Gothic" pitchFamily="34" charset="-122"/>
@@ -7254,7 +7392,7 @@
             </a:avLst>
           </a:prstGeom>
           <a:solidFill>
-            <a:srgbClr val="1E2761"/>
+            <a:srgbClr val="434E60"/>
           </a:solidFill>
           <a:ln/>
         </p:spPr>
@@ -7328,7 +7466,7 @@
             <a:r>
               <a:rPr lang="en-US" sz="1000" dirty="0">
                 <a:solidFill>
-                  <a:srgbClr val="CADCFC"/>
+                  <a:srgbClr val="DCE2EA"/>
                 </a:solidFill>
                 <a:latin typeface="Yu Gothic" pitchFamily="34" charset="0"/>
                 <a:ea typeface="Yu Gothic" pitchFamily="34" charset="-122"/>
@@ -7348,7 +7486,7 @@
             <a:r>
               <a:rPr lang="en-US" sz="1000" dirty="0">
                 <a:solidFill>
-                  <a:srgbClr val="CADCFC"/>
+                  <a:srgbClr val="DCE2EA"/>
                 </a:solidFill>
                 <a:latin typeface="Yu Gothic" pitchFamily="34" charset="0"/>
                 <a:ea typeface="Yu Gothic" pitchFamily="34" charset="-122"/>
@@ -7368,7 +7506,7 @@
             <a:r>
               <a:rPr lang="en-US" sz="1000" dirty="0">
                 <a:solidFill>
-                  <a:srgbClr val="CADCFC"/>
+                  <a:srgbClr val="DCE2EA"/>
                 </a:solidFill>
                 <a:latin typeface="Yu Gothic" pitchFamily="34" charset="0"/>
                 <a:ea typeface="Yu Gothic" pitchFamily="34" charset="-122"/>
@@ -7397,7 +7535,7 @@
             </a:avLst>
           </a:prstGeom>
           <a:solidFill>
-            <a:srgbClr val="F4F7FD"/>
+            <a:srgbClr val="F2F4F7"/>
           </a:solidFill>
           <a:ln/>
         </p:spPr>
@@ -7471,7 +7609,7 @@
             <a:r>
               <a:rPr lang="en-US" sz="1100" dirty="0">
                 <a:solidFill>
-                  <a:srgbClr val="16203F"/>
+                  <a:srgbClr val="232A36"/>
                 </a:solidFill>
                 <a:latin typeface="Yu Gothic" pitchFamily="34" charset="0"/>
                 <a:ea typeface="Yu Gothic" pitchFamily="34" charset="-122"/>
@@ -7500,7 +7638,7 @@
             </a:avLst>
           </a:prstGeom>
           <a:solidFill>
-            <a:srgbClr val="F4F7FD"/>
+            <a:srgbClr val="F2F4F7"/>
           </a:solidFill>
           <a:ln/>
         </p:spPr>
@@ -7532,7 +7670,7 @@
             <a:r>
               <a:rPr lang="en-US" sz="1150" b="1" dirty="0">
                 <a:solidFill>
-                  <a:srgbClr val="5B6485"/>
+                  <a:srgbClr val="636C7C"/>
                 </a:solidFill>
                 <a:latin typeface="Yu Gothic" pitchFamily="34" charset="0"/>
                 <a:ea typeface="Yu Gothic" pitchFamily="34" charset="-122"/>
@@ -7574,7 +7712,7 @@
             <a:r>
               <a:rPr lang="en-US" sz="1100" dirty="0">
                 <a:solidFill>
-                  <a:srgbClr val="16203F"/>
+                  <a:srgbClr val="232A36"/>
                 </a:solidFill>
                 <a:latin typeface="Yu Gothic" pitchFamily="34" charset="0"/>
                 <a:ea typeface="Yu Gothic" pitchFamily="34" charset="-122"/>
@@ -7613,7 +7751,7 @@
             <a:r>
               <a:rPr lang="en-US" sz="1150" b="1" dirty="0">
                 <a:solidFill>
-                  <a:srgbClr val="5B6485"/>
+                  <a:srgbClr val="636C7C"/>
                 </a:solidFill>
                 <a:latin typeface="Yu Gothic" pitchFamily="34" charset="0"/>
                 <a:ea typeface="Yu Gothic" pitchFamily="34" charset="-122"/>
@@ -7659,7 +7797,7 @@
             <a:r>
               <a:rPr lang="en-US" sz="1100" dirty="0">
                 <a:solidFill>
-                  <a:srgbClr val="16203F"/>
+                  <a:srgbClr val="232A36"/>
                 </a:solidFill>
                 <a:latin typeface="Yu Gothic" pitchFamily="34" charset="0"/>
                 <a:ea typeface="Yu Gothic" pitchFamily="34" charset="-122"/>
@@ -7683,7 +7821,7 @@
             <a:r>
               <a:rPr lang="en-US" sz="1100" dirty="0">
                 <a:solidFill>
-                  <a:srgbClr val="16203F"/>
+                  <a:srgbClr val="232A36"/>
                 </a:solidFill>
                 <a:latin typeface="Yu Gothic" pitchFamily="34" charset="0"/>
                 <a:ea typeface="Yu Gothic" pitchFamily="34" charset="-122"/>
@@ -7707,7 +7845,7 @@
             <a:r>
               <a:rPr lang="en-US" sz="1100" dirty="0">
                 <a:solidFill>
-                  <a:srgbClr val="16203F"/>
+                  <a:srgbClr val="232A36"/>
                 </a:solidFill>
                 <a:latin typeface="Yu Gothic" pitchFamily="34" charset="0"/>
                 <a:ea typeface="Yu Gothic" pitchFamily="34" charset="-122"/>
@@ -7731,7 +7869,7 @@
             <a:r>
               <a:rPr lang="en-US" sz="1100" dirty="0">
                 <a:solidFill>
-                  <a:srgbClr val="16203F"/>
+                  <a:srgbClr val="232A36"/>
                 </a:solidFill>
                 <a:latin typeface="Yu Gothic" pitchFamily="34" charset="0"/>
                 <a:ea typeface="Yu Gothic" pitchFamily="34" charset="-122"/>
@@ -7755,7 +7893,7 @@
             <a:r>
               <a:rPr lang="en-US" sz="1100" dirty="0">
                 <a:solidFill>
-                  <a:srgbClr val="16203F"/>
+                  <a:srgbClr val="232A36"/>
                 </a:solidFill>
                 <a:latin typeface="Yu Gothic" pitchFamily="34" charset="0"/>
                 <a:ea typeface="Yu Gothic" pitchFamily="34" charset="-122"/>
@@ -7794,7 +7932,7 @@
             <a:r>
               <a:rPr lang="en-US" sz="1050" dirty="0">
                 <a:solidFill>
-                  <a:srgbClr val="5B6485"/>
+                  <a:srgbClr val="636C7C"/>
                 </a:solidFill>
                 <a:latin typeface="Yu Gothic" pitchFamily="34" charset="0"/>
                 <a:ea typeface="Yu Gothic" pitchFamily="34" charset="-122"/>

</xml_diff>

<commit_message>
Use white backgrounds on every slide in both decks
The dark slate pages are gone; all nine slides are white. Emphasis that the dark
fills used to carry now comes from two tints on white — a neutral one for regular
cards and an accent tint for the thing each slide wants you to look at (the
"what I built" column, the marts stage, the number-verification step, the closing
card). Arrows were darkened to stay visible on white.

Co-Authored-By: Claude Opus 5 <noreply@anthropic.com>
</commit_message>
<xml_diff>
--- a/docs/mini-nowcast-engineering.pptx
+++ b/docs/mini-nowcast-engineering.pptx
@@ -1302,7 +1302,7 @@
     <p:bg>
       <p:bgPr>
         <a:solidFill>
-          <a:srgbClr val="434E60"/>
+          <a:srgbClr val="FFFFFF"/>
         </a:solidFill>
       </p:bgPr>
     </p:bg>
@@ -1347,7 +1347,7 @@
             <a:r>
               <a:rPr lang="en-US" sz="1200" b="1" spc="100" kern="0" dirty="0">
                 <a:solidFill>
-                  <a:srgbClr val="AEBACB"/>
+                  <a:srgbClr val="636C7C"/>
                 </a:solidFill>
                 <a:latin typeface="Yu Gothic" pitchFamily="34" charset="0"/>
                 <a:ea typeface="Yu Gothic" pitchFamily="34" charset="-122"/>
@@ -1386,7 +1386,7 @@
             <a:r>
               <a:rPr lang="en-US" sz="2800" b="1" dirty="0">
                 <a:solidFill>
-                  <a:srgbClr val="FFFFFF"/>
+                  <a:srgbClr val="232A36"/>
                 </a:solidFill>
                 <a:latin typeface="Yu Gothic" pitchFamily="34" charset="0"/>
                 <a:ea typeface="Yu Gothic" pitchFamily="34" charset="-122"/>
@@ -1425,7 +1425,7 @@
             <a:r>
               <a:rPr lang="en-US" sz="1150" b="1" dirty="0">
                 <a:solidFill>
-                  <a:srgbClr val="AEBACB"/>
+                  <a:srgbClr val="636C7C"/>
                 </a:solidFill>
                 <a:latin typeface="Yu Gothic" pitchFamily="34" charset="0"/>
                 <a:ea typeface="Yu Gothic" pitchFamily="34" charset="-122"/>
@@ -1454,7 +1454,7 @@
             </a:avLst>
           </a:prstGeom>
           <a:solidFill>
-            <a:srgbClr val="556175"/>
+            <a:srgbClr val="F2F4F7"/>
           </a:solidFill>
           <a:ln/>
         </p:spPr>
@@ -1486,7 +1486,7 @@
             <a:r>
               <a:rPr lang="en-US" sz="1150" b="1" dirty="0">
                 <a:solidFill>
-                  <a:srgbClr val="FFFFFF"/>
+                  <a:srgbClr val="232A36"/>
                 </a:solidFill>
                 <a:latin typeface="Yu Gothic" pitchFamily="34" charset="0"/>
                 <a:ea typeface="Yu Gothic" pitchFamily="34" charset="-122"/>
@@ -1528,7 +1528,7 @@
             <a:r>
               <a:rPr lang="en-US" sz="950" dirty="0">
                 <a:solidFill>
-                  <a:srgbClr val="DCE2EA"/>
+                  <a:srgbClr val="636C7C"/>
                 </a:solidFill>
                 <a:latin typeface="Yu Gothic" pitchFamily="34" charset="0"/>
                 <a:ea typeface="Yu Gothic" pitchFamily="34" charset="-122"/>
@@ -1555,7 +1555,7 @@
             <a:avLst/>
           </a:prstGeom>
           <a:solidFill>
-            <a:srgbClr val="AEBACB"/>
+            <a:srgbClr val="556175"/>
           </a:solidFill>
           <a:ln/>
         </p:spPr>
@@ -1577,7 +1577,7 @@
             </a:avLst>
           </a:prstGeom>
           <a:solidFill>
-            <a:srgbClr val="556175"/>
+            <a:srgbClr val="F2F4F7"/>
           </a:solidFill>
           <a:ln/>
         </p:spPr>
@@ -1609,7 +1609,7 @@
             <a:r>
               <a:rPr lang="en-US" sz="1150" b="1" dirty="0">
                 <a:solidFill>
-                  <a:srgbClr val="FFFFFF"/>
+                  <a:srgbClr val="232A36"/>
                 </a:solidFill>
                 <a:latin typeface="Yu Gothic" pitchFamily="34" charset="0"/>
                 <a:ea typeface="Yu Gothic" pitchFamily="34" charset="-122"/>
@@ -1651,7 +1651,7 @@
             <a:r>
               <a:rPr lang="en-US" sz="950" dirty="0">
                 <a:solidFill>
-                  <a:srgbClr val="DCE2EA"/>
+                  <a:srgbClr val="636C7C"/>
                 </a:solidFill>
                 <a:latin typeface="Yu Gothic" pitchFamily="34" charset="0"/>
                 <a:ea typeface="Yu Gothic" pitchFamily="34" charset="-122"/>
@@ -1678,7 +1678,7 @@
             <a:avLst/>
           </a:prstGeom>
           <a:solidFill>
-            <a:srgbClr val="AEBACB"/>
+            <a:srgbClr val="556175"/>
           </a:solidFill>
           <a:ln/>
         </p:spPr>
@@ -1700,7 +1700,7 @@
             </a:avLst>
           </a:prstGeom>
           <a:solidFill>
-            <a:srgbClr val="556175"/>
+            <a:srgbClr val="F2F4F7"/>
           </a:solidFill>
           <a:ln/>
         </p:spPr>
@@ -1732,7 +1732,7 @@
             <a:r>
               <a:rPr lang="en-US" sz="1150" b="1" dirty="0">
                 <a:solidFill>
-                  <a:srgbClr val="FFFFFF"/>
+                  <a:srgbClr val="232A36"/>
                 </a:solidFill>
                 <a:latin typeface="Yu Gothic" pitchFamily="34" charset="0"/>
                 <a:ea typeface="Yu Gothic" pitchFamily="34" charset="-122"/>
@@ -1774,7 +1774,7 @@
             <a:r>
               <a:rPr lang="en-US" sz="950" dirty="0">
                 <a:solidFill>
-                  <a:srgbClr val="DCE2EA"/>
+                  <a:srgbClr val="636C7C"/>
                 </a:solidFill>
                 <a:latin typeface="Yu Gothic" pitchFamily="34" charset="0"/>
                 <a:ea typeface="Yu Gothic" pitchFamily="34" charset="-122"/>
@@ -1801,7 +1801,7 @@
             <a:avLst/>
           </a:prstGeom>
           <a:solidFill>
-            <a:srgbClr val="AEBACB"/>
+            <a:srgbClr val="556175"/>
           </a:solidFill>
           <a:ln/>
         </p:spPr>
@@ -1833,7 +1833,7 @@
             <a:r>
               <a:rPr lang="en-US" sz="950" dirty="0">
                 <a:solidFill>
-                  <a:srgbClr val="AEBACB"/>
+                  <a:srgbClr val="636C7C"/>
                 </a:solidFill>
                 <a:latin typeface="Yu Gothic" pitchFamily="34" charset="0"/>
                 <a:ea typeface="Yu Gothic" pitchFamily="34" charset="-122"/>
@@ -1872,7 +1872,7 @@
             <a:r>
               <a:rPr lang="en-US" sz="1150" b="1" dirty="0">
                 <a:solidFill>
-                  <a:srgbClr val="AEBACB"/>
+                  <a:srgbClr val="636C7C"/>
                 </a:solidFill>
                 <a:latin typeface="Yu Gothic" pitchFamily="34" charset="0"/>
                 <a:ea typeface="Yu Gothic" pitchFamily="34" charset="-122"/>
@@ -1901,7 +1901,7 @@
             </a:avLst>
           </a:prstGeom>
           <a:solidFill>
-            <a:srgbClr val="556175"/>
+            <a:srgbClr val="F2F4F7"/>
           </a:solidFill>
           <a:ln/>
         </p:spPr>
@@ -1933,7 +1933,7 @@
             <a:r>
               <a:rPr lang="en-US" sz="1150" b="1" dirty="0">
                 <a:solidFill>
-                  <a:srgbClr val="FFFFFF"/>
+                  <a:srgbClr val="232A36"/>
                 </a:solidFill>
                 <a:latin typeface="Yu Gothic" pitchFamily="34" charset="0"/>
                 <a:ea typeface="Yu Gothic" pitchFamily="34" charset="-122"/>
@@ -1975,7 +1975,7 @@
             <a:r>
               <a:rPr lang="en-US" sz="950" dirty="0">
                 <a:solidFill>
-                  <a:srgbClr val="DCE2EA"/>
+                  <a:srgbClr val="636C7C"/>
                 </a:solidFill>
                 <a:latin typeface="Yu Gothic" pitchFamily="34" charset="0"/>
                 <a:ea typeface="Yu Gothic" pitchFamily="34" charset="-122"/>
@@ -2002,7 +2002,7 @@
             <a:avLst/>
           </a:prstGeom>
           <a:solidFill>
-            <a:srgbClr val="AEBACB"/>
+            <a:srgbClr val="556175"/>
           </a:solidFill>
           <a:ln/>
         </p:spPr>
@@ -2024,7 +2024,7 @@
             </a:avLst>
           </a:prstGeom>
           <a:solidFill>
-            <a:srgbClr val="556175"/>
+            <a:srgbClr val="F2F4F7"/>
           </a:solidFill>
           <a:ln/>
         </p:spPr>
@@ -2056,7 +2056,7 @@
             <a:r>
               <a:rPr lang="en-US" sz="1150" b="1" dirty="0">
                 <a:solidFill>
-                  <a:srgbClr val="FFFFFF"/>
+                  <a:srgbClr val="232A36"/>
                 </a:solidFill>
                 <a:latin typeface="Yu Gothic" pitchFamily="34" charset="0"/>
                 <a:ea typeface="Yu Gothic" pitchFamily="34" charset="-122"/>
@@ -2098,7 +2098,7 @@
             <a:r>
               <a:rPr lang="en-US" sz="950" dirty="0">
                 <a:solidFill>
-                  <a:srgbClr val="DCE2EA"/>
+                  <a:srgbClr val="636C7C"/>
                 </a:solidFill>
                 <a:latin typeface="Yu Gothic" pitchFamily="34" charset="0"/>
                 <a:ea typeface="Yu Gothic" pitchFamily="34" charset="-122"/>
@@ -2125,7 +2125,7 @@
             <a:avLst/>
           </a:prstGeom>
           <a:solidFill>
-            <a:srgbClr val="AEBACB"/>
+            <a:srgbClr val="556175"/>
           </a:solidFill>
           <a:ln/>
         </p:spPr>
@@ -2147,7 +2147,7 @@
             </a:avLst>
           </a:prstGeom>
           <a:solidFill>
-            <a:srgbClr val="DCE2EA"/>
+            <a:srgbClr val="FBEDE6"/>
           </a:solidFill>
           <a:ln/>
         </p:spPr>
@@ -2179,7 +2179,7 @@
             <a:r>
               <a:rPr lang="en-US" sz="1150" b="1" dirty="0">
                 <a:solidFill>
-                  <a:srgbClr val="434E60"/>
+                  <a:srgbClr val="EB6834"/>
                 </a:solidFill>
                 <a:latin typeface="Yu Gothic" pitchFamily="34" charset="0"/>
                 <a:ea typeface="Yu Gothic" pitchFamily="34" charset="-122"/>
@@ -2221,7 +2221,7 @@
             <a:r>
               <a:rPr lang="en-US" sz="950" dirty="0">
                 <a:solidFill>
-                  <a:srgbClr val="434E60"/>
+                  <a:srgbClr val="636C7C"/>
                 </a:solidFill>
                 <a:latin typeface="Yu Gothic" pitchFamily="34" charset="0"/>
                 <a:ea typeface="Yu Gothic" pitchFamily="34" charset="-122"/>
@@ -2248,7 +2248,7 @@
             <a:avLst/>
           </a:prstGeom>
           <a:solidFill>
-            <a:srgbClr val="AEBACB"/>
+            <a:srgbClr val="556175"/>
           </a:solidFill>
           <a:ln/>
         </p:spPr>
@@ -2280,7 +2280,7 @@
             <a:r>
               <a:rPr lang="en-US" sz="950" dirty="0">
                 <a:solidFill>
-                  <a:srgbClr val="AEBACB"/>
+                  <a:srgbClr val="636C7C"/>
                 </a:solidFill>
                 <a:latin typeface="Yu Gothic" pitchFamily="34" charset="0"/>
                 <a:ea typeface="Yu Gothic" pitchFamily="34" charset="-122"/>
@@ -2319,7 +2319,7 @@
             <a:r>
               <a:rPr lang="en-US" sz="1150" b="1" dirty="0">
                 <a:solidFill>
-                  <a:srgbClr val="AEBACB"/>
+                  <a:srgbClr val="636C7C"/>
                 </a:solidFill>
                 <a:latin typeface="Yu Gothic" pitchFamily="34" charset="0"/>
                 <a:ea typeface="Yu Gothic" pitchFamily="34" charset="-122"/>
@@ -2348,7 +2348,7 @@
             </a:avLst>
           </a:prstGeom>
           <a:solidFill>
-            <a:srgbClr val="556175"/>
+            <a:srgbClr val="F2F4F7"/>
           </a:solidFill>
           <a:ln/>
         </p:spPr>
@@ -2380,7 +2380,7 @@
             <a:r>
               <a:rPr lang="en-US" sz="1150" b="1" dirty="0">
                 <a:solidFill>
-                  <a:srgbClr val="FFFFFF"/>
+                  <a:srgbClr val="232A36"/>
                 </a:solidFill>
                 <a:latin typeface="Yu Gothic" pitchFamily="34" charset="0"/>
                 <a:ea typeface="Yu Gothic" pitchFamily="34" charset="-122"/>
@@ -2422,7 +2422,7 @@
             <a:r>
               <a:rPr lang="en-US" sz="950" dirty="0">
                 <a:solidFill>
-                  <a:srgbClr val="DCE2EA"/>
+                  <a:srgbClr val="636C7C"/>
                 </a:solidFill>
                 <a:latin typeface="Yu Gothic" pitchFamily="34" charset="0"/>
                 <a:ea typeface="Yu Gothic" pitchFamily="34" charset="-122"/>
@@ -2451,7 +2451,7 @@
             </a:avLst>
           </a:prstGeom>
           <a:solidFill>
-            <a:srgbClr val="556175"/>
+            <a:srgbClr val="F2F4F7"/>
           </a:solidFill>
           <a:ln/>
         </p:spPr>
@@ -2483,7 +2483,7 @@
             <a:r>
               <a:rPr lang="en-US" sz="1150" b="1" dirty="0">
                 <a:solidFill>
-                  <a:srgbClr val="FFFFFF"/>
+                  <a:srgbClr val="232A36"/>
                 </a:solidFill>
                 <a:latin typeface="Yu Gothic" pitchFamily="34" charset="0"/>
                 <a:ea typeface="Yu Gothic" pitchFamily="34" charset="-122"/>
@@ -2525,7 +2525,7 @@
             <a:r>
               <a:rPr lang="en-US" sz="950" dirty="0">
                 <a:solidFill>
-                  <a:srgbClr val="DCE2EA"/>
+                  <a:srgbClr val="636C7C"/>
                 </a:solidFill>
                 <a:latin typeface="Yu Gothic" pitchFamily="34" charset="0"/>
                 <a:ea typeface="Yu Gothic" pitchFamily="34" charset="-122"/>
@@ -2564,7 +2564,7 @@
             <a:r>
               <a:rPr lang="en-US" sz="1150" b="1" dirty="0">
                 <a:solidFill>
-                  <a:srgbClr val="AEBACB"/>
+                  <a:srgbClr val="636C7C"/>
                 </a:solidFill>
                 <a:latin typeface="Yu Gothic" pitchFamily="34" charset="0"/>
                 <a:ea typeface="Yu Gothic" pitchFamily="34" charset="-122"/>
@@ -2606,7 +2606,7 @@
             <a:r>
               <a:rPr lang="en-US" sz="1000" dirty="0">
                 <a:solidFill>
-                  <a:srgbClr val="DCE2EA"/>
+                  <a:srgbClr val="232A36"/>
                 </a:solidFill>
                 <a:latin typeface="Yu Gothic" pitchFamily="34" charset="0"/>
                 <a:ea typeface="Yu Gothic" pitchFamily="34" charset="-122"/>
@@ -5972,7 +5972,7 @@
             <a:avLst/>
           </a:prstGeom>
           <a:solidFill>
-            <a:srgbClr val="AEBACB"/>
+            <a:srgbClr val="556175"/>
           </a:solidFill>
           <a:ln/>
         </p:spPr>
@@ -6115,7 +6115,7 @@
             <a:avLst/>
           </a:prstGeom>
           <a:solidFill>
-            <a:srgbClr val="AEBACB"/>
+            <a:srgbClr val="556175"/>
           </a:solidFill>
           <a:ln/>
         </p:spPr>
@@ -6258,7 +6258,7 @@
             <a:avLst/>
           </a:prstGeom>
           <a:solidFill>
-            <a:srgbClr val="AEBACB"/>
+            <a:srgbClr val="556175"/>
           </a:solidFill>
           <a:ln/>
         </p:spPr>
@@ -6401,7 +6401,7 @@
             <a:avLst/>
           </a:prstGeom>
           <a:solidFill>
-            <a:srgbClr val="AEBACB"/>
+            <a:srgbClr val="556175"/>
           </a:solidFill>
           <a:ln/>
         </p:spPr>
@@ -6544,7 +6544,7 @@
             <a:avLst/>
           </a:prstGeom>
           <a:solidFill>
-            <a:srgbClr val="AEBACB"/>
+            <a:srgbClr val="556175"/>
           </a:solidFill>
           <a:ln/>
         </p:spPr>
@@ -6566,7 +6566,7 @@
             </a:avLst>
           </a:prstGeom>
           <a:solidFill>
-            <a:srgbClr val="DCE2EA"/>
+            <a:srgbClr val="FBEDE6"/>
           </a:solidFill>
           <a:ln/>
         </p:spPr>
@@ -6598,7 +6598,7 @@
             <a:r>
               <a:rPr lang="en-US" sz="1200" b="1" dirty="0">
                 <a:solidFill>
-                  <a:srgbClr val="434E60"/>
+                  <a:srgbClr val="EB6834"/>
                 </a:solidFill>
                 <a:latin typeface="Yu Gothic" pitchFamily="34" charset="0"/>
                 <a:ea typeface="Yu Gothic" pitchFamily="34" charset="-122"/>
@@ -6640,7 +6640,7 @@
             <a:r>
               <a:rPr lang="en-US" sz="1000" dirty="0">
                 <a:solidFill>
-                  <a:srgbClr val="434E60"/>
+                  <a:srgbClr val="232A36"/>
                 </a:solidFill>
                 <a:latin typeface="Yu Gothic" pitchFamily="34" charset="0"/>
                 <a:ea typeface="Yu Gothic" pitchFamily="34" charset="-122"/>
@@ -6660,7 +6660,7 @@
             <a:r>
               <a:rPr lang="en-US" sz="1000" dirty="0">
                 <a:solidFill>
-                  <a:srgbClr val="434E60"/>
+                  <a:srgbClr val="232A36"/>
                 </a:solidFill>
                 <a:latin typeface="Yu Gothic" pitchFamily="34" charset="0"/>
                 <a:ea typeface="Yu Gothic" pitchFamily="34" charset="-122"/>
@@ -7126,7 +7126,7 @@
             </a:avLst>
           </a:prstGeom>
           <a:solidFill>
-            <a:srgbClr val="434E60"/>
+            <a:srgbClr val="E6EAF0"/>
           </a:solidFill>
           <a:ln/>
         </p:spPr>
@@ -7158,7 +7158,7 @@
             <a:r>
               <a:rPr lang="en-US" sz="2600" b="1" dirty="0">
                 <a:solidFill>
-                  <a:srgbClr val="FFFFFF"/>
+                  <a:srgbClr val="232A36"/>
                 </a:solidFill>
                 <a:latin typeface="Yu Gothic" pitchFamily="34" charset="0"/>
                 <a:ea typeface="Yu Gothic" pitchFamily="34" charset="-122"/>
@@ -7200,7 +7200,7 @@
             <a:r>
               <a:rPr lang="en-US" sz="1000" dirty="0">
                 <a:solidFill>
-                  <a:srgbClr val="DCE2EA"/>
+                  <a:srgbClr val="636C7C"/>
                 </a:solidFill>
                 <a:latin typeface="Yu Gothic" pitchFamily="34" charset="0"/>
                 <a:ea typeface="Yu Gothic" pitchFamily="34" charset="-122"/>
@@ -7220,7 +7220,7 @@
             <a:r>
               <a:rPr lang="en-US" sz="1000" dirty="0">
                 <a:solidFill>
-                  <a:srgbClr val="DCE2EA"/>
+                  <a:srgbClr val="636C7C"/>
                 </a:solidFill>
                 <a:latin typeface="Yu Gothic" pitchFamily="34" charset="0"/>
                 <a:ea typeface="Yu Gothic" pitchFamily="34" charset="-122"/>
@@ -7240,7 +7240,7 @@
             <a:r>
               <a:rPr lang="en-US" sz="1000" dirty="0">
                 <a:solidFill>
-                  <a:srgbClr val="DCE2EA"/>
+                  <a:srgbClr val="636C7C"/>
                 </a:solidFill>
                 <a:latin typeface="Yu Gothic" pitchFamily="34" charset="0"/>
                 <a:ea typeface="Yu Gothic" pitchFamily="34" charset="-122"/>
@@ -7269,7 +7269,7 @@
             </a:avLst>
           </a:prstGeom>
           <a:solidFill>
-            <a:srgbClr val="434E60"/>
+            <a:srgbClr val="E6EAF0"/>
           </a:solidFill>
           <a:ln/>
         </p:spPr>
@@ -7301,7 +7301,7 @@
             <a:r>
               <a:rPr lang="en-US" sz="2600" b="1" dirty="0">
                 <a:solidFill>
-                  <a:srgbClr val="FFFFFF"/>
+                  <a:srgbClr val="232A36"/>
                 </a:solidFill>
                 <a:latin typeface="Yu Gothic" pitchFamily="34" charset="0"/>
                 <a:ea typeface="Yu Gothic" pitchFamily="34" charset="-122"/>
@@ -7343,7 +7343,7 @@
             <a:r>
               <a:rPr lang="en-US" sz="1000" dirty="0">
                 <a:solidFill>
-                  <a:srgbClr val="DCE2EA"/>
+                  <a:srgbClr val="636C7C"/>
                 </a:solidFill>
                 <a:latin typeface="Yu Gothic" pitchFamily="34" charset="0"/>
                 <a:ea typeface="Yu Gothic" pitchFamily="34" charset="-122"/>
@@ -7363,7 +7363,7 @@
             <a:r>
               <a:rPr lang="en-US" sz="1000" dirty="0">
                 <a:solidFill>
-                  <a:srgbClr val="DCE2EA"/>
+                  <a:srgbClr val="636C7C"/>
                 </a:solidFill>
                 <a:latin typeface="Yu Gothic" pitchFamily="34" charset="0"/>
                 <a:ea typeface="Yu Gothic" pitchFamily="34" charset="-122"/>
@@ -7392,7 +7392,7 @@
             </a:avLst>
           </a:prstGeom>
           <a:solidFill>
-            <a:srgbClr val="434E60"/>
+            <a:srgbClr val="E6EAF0"/>
           </a:solidFill>
           <a:ln/>
         </p:spPr>
@@ -7424,7 +7424,7 @@
             <a:r>
               <a:rPr lang="en-US" sz="2600" b="1" dirty="0">
                 <a:solidFill>
-                  <a:srgbClr val="FFFFFF"/>
+                  <a:srgbClr val="232A36"/>
                 </a:solidFill>
                 <a:latin typeface="Yu Gothic" pitchFamily="34" charset="0"/>
                 <a:ea typeface="Yu Gothic" pitchFamily="34" charset="-122"/>
@@ -7466,7 +7466,7 @@
             <a:r>
               <a:rPr lang="en-US" sz="1000" dirty="0">
                 <a:solidFill>
-                  <a:srgbClr val="DCE2EA"/>
+                  <a:srgbClr val="636C7C"/>
                 </a:solidFill>
                 <a:latin typeface="Yu Gothic" pitchFamily="34" charset="0"/>
                 <a:ea typeface="Yu Gothic" pitchFamily="34" charset="-122"/>
@@ -7486,7 +7486,7 @@
             <a:r>
               <a:rPr lang="en-US" sz="1000" dirty="0">
                 <a:solidFill>
-                  <a:srgbClr val="DCE2EA"/>
+                  <a:srgbClr val="636C7C"/>
                 </a:solidFill>
                 <a:latin typeface="Yu Gothic" pitchFamily="34" charset="0"/>
                 <a:ea typeface="Yu Gothic" pitchFamily="34" charset="-122"/>
@@ -7506,7 +7506,7 @@
             <a:r>
               <a:rPr lang="en-US" sz="1000" dirty="0">
                 <a:solidFill>
-                  <a:srgbClr val="DCE2EA"/>
+                  <a:srgbClr val="636C7C"/>
                 </a:solidFill>
                 <a:latin typeface="Yu Gothic" pitchFamily="34" charset="0"/>
                 <a:ea typeface="Yu Gothic" pitchFamily="34" charset="-122"/>

</xml_diff>